<commit_message>
Sequence diagrams: generic dual entry point and generic bank outcome
Android/iOS diagrams now show "Scan with Camera — or tap the QR image
on a webpage" as the trigger (both are valid ways to reach the same
link), and resolve to a generic "Bank X app" instead of hardcoding
Bank A, since the chooser/picker can end in any of the 3 banks.
</commit_message>
<xml_diff>
--- a/SGQR_Sequence_Diagrams.pptx
+++ b/SGQR_Sequence_Diagrams.pptx
@@ -1139,8 +1139,8 @@
         </p:nvSpPr>
         <p:spPr>
           <a:xfrm>
-            <a:off x="182880" y="1188720"/>
-            <a:ext cx="1737360" cy="457200"/>
+            <a:off x="137160" y="1188720"/>
+            <a:ext cx="1828800" cy="457200"/>
           </a:xfrm>
           <a:prstGeom prst="roundRect">
             <a:avLst>
@@ -1161,8 +1161,8 @@
         </p:nvSpPr>
         <p:spPr>
           <a:xfrm>
-            <a:off x="182880" y="1188720"/>
-            <a:ext cx="1737360" cy="457200"/>
+            <a:off x="137160" y="1188720"/>
+            <a:ext cx="1828800" cy="457200"/>
           </a:xfrm>
           <a:prstGeom prst="rect">
             <a:avLst/>
@@ -1178,7 +1178,7 @@
               <a:buNone/>
             </a:pPr>
             <a:r>
-              <a:rPr lang="en-US" sz="1250" b="1" dirty="0">
+              <a:rPr lang="en-US" sz="1100" b="1" dirty="0">
                 <a:solidFill>
                   <a:srgbClr val="FFFFFF"/>
                 </a:solidFill>
@@ -1188,7 +1188,7 @@
               </a:rPr>
               <a:t>User</a:t>
             </a:r>
-            <a:endParaRPr lang="en-US" sz="1250" dirty="0"/>
+            <a:endParaRPr lang="en-US" sz="1100" dirty="0"/>
           </a:p>
         </p:txBody>
       </p:sp>
@@ -1223,8 +1223,8 @@
         </p:nvSpPr>
         <p:spPr>
           <a:xfrm>
-            <a:off x="2194560" y="1188720"/>
-            <a:ext cx="1737360" cy="457200"/>
+            <a:off x="2148840" y="1188720"/>
+            <a:ext cx="1828800" cy="457200"/>
           </a:xfrm>
           <a:prstGeom prst="roundRect">
             <a:avLst>
@@ -1245,8 +1245,8 @@
         </p:nvSpPr>
         <p:spPr>
           <a:xfrm>
-            <a:off x="2194560" y="1188720"/>
-            <a:ext cx="1737360" cy="457200"/>
+            <a:off x="2148840" y="1188720"/>
+            <a:ext cx="1828800" cy="457200"/>
           </a:xfrm>
           <a:prstGeom prst="rect">
             <a:avLst/>
@@ -1262,7 +1262,7 @@
               <a:buNone/>
             </a:pPr>
             <a:r>
-              <a:rPr lang="en-US" sz="1250" b="1" dirty="0">
+              <a:rPr lang="en-US" sz="1100" b="1" dirty="0">
                 <a:solidFill>
                   <a:srgbClr val="FFFFFF"/>
                 </a:solidFill>
@@ -1270,9 +1270,9 @@
                 <a:ea typeface="Calibri" pitchFamily="34" charset="-122"/>
                 <a:cs typeface="Calibri" pitchFamily="34" charset="-120"/>
               </a:rPr>
-              <a:t>Camera</a:t>
-            </a:r>
-            <a:endParaRPr lang="en-US" sz="1250" dirty="0"/>
+              <a:t>Camera / QR tap</a:t>
+            </a:r>
+            <a:endParaRPr lang="en-US" sz="1100" dirty="0"/>
           </a:p>
         </p:txBody>
       </p:sp>
@@ -1307,8 +1307,8 @@
         </p:nvSpPr>
         <p:spPr>
           <a:xfrm>
-            <a:off x="4206240" y="1188720"/>
-            <a:ext cx="1737360" cy="457200"/>
+            <a:off x="4160520" y="1188720"/>
+            <a:ext cx="1828800" cy="457200"/>
           </a:xfrm>
           <a:prstGeom prst="roundRect">
             <a:avLst>
@@ -1329,8 +1329,8 @@
         </p:nvSpPr>
         <p:spPr>
           <a:xfrm>
-            <a:off x="4206240" y="1188720"/>
-            <a:ext cx="1737360" cy="457200"/>
+            <a:off x="4160520" y="1188720"/>
+            <a:ext cx="1828800" cy="457200"/>
           </a:xfrm>
           <a:prstGeom prst="rect">
             <a:avLst/>
@@ -1346,7 +1346,7 @@
               <a:buNone/>
             </a:pPr>
             <a:r>
-              <a:rPr lang="en-US" sz="1250" b="1" dirty="0">
+              <a:rPr lang="en-US" sz="1100" b="1" dirty="0">
                 <a:solidFill>
                   <a:srgbClr val="FFFFFF"/>
                 </a:solidFill>
@@ -1356,7 +1356,7 @@
               </a:rPr>
               <a:t>Android OS</a:t>
             </a:r>
-            <a:endParaRPr lang="en-US" sz="1250" dirty="0"/>
+            <a:endParaRPr lang="en-US" sz="1100" dirty="0"/>
           </a:p>
         </p:txBody>
       </p:sp>
@@ -1391,8 +1391,8 @@
         </p:nvSpPr>
         <p:spPr>
           <a:xfrm>
-            <a:off x="6217920" y="1188720"/>
-            <a:ext cx="1737360" cy="457200"/>
+            <a:off x="6172200" y="1188720"/>
+            <a:ext cx="1828800" cy="457200"/>
           </a:xfrm>
           <a:prstGeom prst="roundRect">
             <a:avLst>
@@ -1413,8 +1413,8 @@
         </p:nvSpPr>
         <p:spPr>
           <a:xfrm>
-            <a:off x="6217920" y="1188720"/>
-            <a:ext cx="1737360" cy="457200"/>
+            <a:off x="6172200" y="1188720"/>
+            <a:ext cx="1828800" cy="457200"/>
           </a:xfrm>
           <a:prstGeom prst="rect">
             <a:avLst/>
@@ -1430,7 +1430,7 @@
               <a:buNone/>
             </a:pPr>
             <a:r>
-              <a:rPr lang="en-US" sz="1250" b="1" dirty="0">
+              <a:rPr lang="en-US" sz="1100" b="1" dirty="0">
                 <a:solidFill>
                   <a:srgbClr val="FFFFFF"/>
                 </a:solidFill>
@@ -1440,7 +1440,7 @@
               </a:rPr>
               <a:t>Chrome</a:t>
             </a:r>
-            <a:endParaRPr lang="en-US" sz="1250" dirty="0"/>
+            <a:endParaRPr lang="en-US" sz="1100" dirty="0"/>
           </a:p>
         </p:txBody>
       </p:sp>
@@ -1475,8 +1475,8 @@
         </p:nvSpPr>
         <p:spPr>
           <a:xfrm>
-            <a:off x="8229600" y="1188720"/>
-            <a:ext cx="1737360" cy="457200"/>
+            <a:off x="8183880" y="1188720"/>
+            <a:ext cx="1828800" cy="457200"/>
           </a:xfrm>
           <a:prstGeom prst="roundRect">
             <a:avLst>
@@ -1497,8 +1497,8 @@
         </p:nvSpPr>
         <p:spPr>
           <a:xfrm>
-            <a:off x="8229600" y="1188720"/>
-            <a:ext cx="1737360" cy="457200"/>
+            <a:off x="8183880" y="1188720"/>
+            <a:ext cx="1828800" cy="457200"/>
           </a:xfrm>
           <a:prstGeom prst="rect">
             <a:avLst/>
@@ -1514,7 +1514,7 @@
               <a:buNone/>
             </a:pPr>
             <a:r>
-              <a:rPr lang="en-US" sz="1250" b="1" dirty="0">
+              <a:rPr lang="en-US" sz="1100" b="1" dirty="0">
                 <a:solidFill>
                   <a:srgbClr val="FFFFFF"/>
                 </a:solidFill>
@@ -1524,7 +1524,7 @@
               </a:rPr>
               <a:t>Backend</a:t>
             </a:r>
-            <a:endParaRPr lang="en-US" sz="1250" dirty="0"/>
+            <a:endParaRPr lang="en-US" sz="1100" dirty="0"/>
           </a:p>
         </p:txBody>
       </p:sp>
@@ -1559,8 +1559,8 @@
         </p:nvSpPr>
         <p:spPr>
           <a:xfrm>
-            <a:off x="10241280" y="1188720"/>
-            <a:ext cx="1737360" cy="457200"/>
+            <a:off x="10195560" y="1188720"/>
+            <a:ext cx="1828800" cy="457200"/>
           </a:xfrm>
           <a:prstGeom prst="roundRect">
             <a:avLst>
@@ -1568,7 +1568,7 @@
             </a:avLst>
           </a:prstGeom>
           <a:solidFill>
-            <a:srgbClr val="E63946"/>
+            <a:srgbClr val="5B6B79"/>
           </a:solidFill>
           <a:ln/>
         </p:spPr>
@@ -1581,8 +1581,8 @@
         </p:nvSpPr>
         <p:spPr>
           <a:xfrm>
-            <a:off x="10241280" y="1188720"/>
-            <a:ext cx="1737360" cy="457200"/>
+            <a:off x="10195560" y="1188720"/>
+            <a:ext cx="1828800" cy="457200"/>
           </a:xfrm>
           <a:prstGeom prst="rect">
             <a:avLst/>
@@ -1598,7 +1598,7 @@
               <a:buNone/>
             </a:pPr>
             <a:r>
-              <a:rPr lang="en-US" sz="1250" b="1" dirty="0">
+              <a:rPr lang="en-US" sz="1100" b="1" dirty="0">
                 <a:solidFill>
                   <a:srgbClr val="FFFFFF"/>
                 </a:solidFill>
@@ -1606,9 +1606,9 @@
                 <a:ea typeface="Calibri" pitchFamily="34" charset="-122"/>
                 <a:cs typeface="Calibri" pitchFamily="34" charset="-120"/>
               </a:rPr>
-              <a:t>Bank A app</a:t>
-            </a:r>
-            <a:endParaRPr lang="en-US" sz="1250" dirty="0"/>
+              <a:t>Bank X app</a:t>
+            </a:r>
+            <a:endParaRPr lang="en-US" sz="1100" dirty="0"/>
           </a:p>
         </p:txBody>
       </p:sp>
@@ -1668,7 +1668,7 @@
                 <a:ea typeface="Calibri" pitchFamily="34" charset="-122"/>
                 <a:cs typeface="Calibri" pitchFamily="34" charset="-120"/>
               </a:rPr>
-              <a:t>Scan QR code</a:t>
+              <a:t>Scan with Camera — or tap the QR image on a webpage</a:t>
             </a:r>
             <a:endParaRPr lang="en-US" sz="1000" dirty="0"/>
           </a:p>
@@ -2175,7 +2175,7 @@
                 <a:ea typeface="Calibri" pitchFamily="34" charset="-122"/>
                 <a:cs typeface="Calibri" pitchFamily="34" charset="-120"/>
               </a:rPr>
-              <a:t>Pick Bank A</a:t>
+              <a:t>Pick one bank (A, B, or C)</a:t>
             </a:r>
             <a:endParaRPr lang="en-US" sz="1000" dirty="0"/>
           </a:p>
@@ -2238,7 +2238,7 @@
                 <a:ea typeface="Calibri" pitchFamily="34" charset="-122"/>
                 <a:cs typeface="Calibri" pitchFamily="34" charset="-120"/>
               </a:rPr>
-              <a:t>Launch with sgqrpay://pay?token=…</a:t>
+              <a:t>Launch chosen bank with sgqrpay://pay?token=…</a:t>
             </a:r>
             <a:endParaRPr lang="en-US" sz="1000" dirty="0"/>
           </a:p>
@@ -2512,8 +2512,8 @@
         </p:nvSpPr>
         <p:spPr>
           <a:xfrm>
-            <a:off x="182880" y="1188720"/>
-            <a:ext cx="1737360" cy="457200"/>
+            <a:off x="137160" y="1188720"/>
+            <a:ext cx="1828800" cy="457200"/>
           </a:xfrm>
           <a:prstGeom prst="roundRect">
             <a:avLst>
@@ -2534,8 +2534,8 @@
         </p:nvSpPr>
         <p:spPr>
           <a:xfrm>
-            <a:off x="182880" y="1188720"/>
-            <a:ext cx="1737360" cy="457200"/>
+            <a:off x="137160" y="1188720"/>
+            <a:ext cx="1828800" cy="457200"/>
           </a:xfrm>
           <a:prstGeom prst="rect">
             <a:avLst/>
@@ -2551,7 +2551,7 @@
               <a:buNone/>
             </a:pPr>
             <a:r>
-              <a:rPr lang="en-US" sz="1250" b="1" dirty="0">
+              <a:rPr lang="en-US" sz="1100" b="1" dirty="0">
                 <a:solidFill>
                   <a:srgbClr val="FFFFFF"/>
                 </a:solidFill>
@@ -2561,7 +2561,7 @@
               </a:rPr>
               <a:t>User</a:t>
             </a:r>
-            <a:endParaRPr lang="en-US" sz="1250" dirty="0"/>
+            <a:endParaRPr lang="en-US" sz="1100" dirty="0"/>
           </a:p>
         </p:txBody>
       </p:sp>
@@ -2596,8 +2596,8 @@
         </p:nvSpPr>
         <p:spPr>
           <a:xfrm>
-            <a:off x="2194560" y="1188720"/>
-            <a:ext cx="1737360" cy="457200"/>
+            <a:off x="2148840" y="1188720"/>
+            <a:ext cx="1828800" cy="457200"/>
           </a:xfrm>
           <a:prstGeom prst="roundRect">
             <a:avLst>
@@ -2618,8 +2618,8 @@
         </p:nvSpPr>
         <p:spPr>
           <a:xfrm>
-            <a:off x="2194560" y="1188720"/>
-            <a:ext cx="1737360" cy="457200"/>
+            <a:off x="2148840" y="1188720"/>
+            <a:ext cx="1828800" cy="457200"/>
           </a:xfrm>
           <a:prstGeom prst="rect">
             <a:avLst/>
@@ -2635,7 +2635,7 @@
               <a:buNone/>
             </a:pPr>
             <a:r>
-              <a:rPr lang="en-US" sz="1250" b="1" dirty="0">
+              <a:rPr lang="en-US" sz="1100" b="1" dirty="0">
                 <a:solidFill>
                   <a:srgbClr val="FFFFFF"/>
                 </a:solidFill>
@@ -2643,9 +2643,9 @@
                 <a:ea typeface="Calibri" pitchFamily="34" charset="-122"/>
                 <a:cs typeface="Calibri" pitchFamily="34" charset="-120"/>
               </a:rPr>
-              <a:t>Camera</a:t>
-            </a:r>
-            <a:endParaRPr lang="en-US" sz="1250" dirty="0"/>
+              <a:t>Camera / QR tap</a:t>
+            </a:r>
+            <a:endParaRPr lang="en-US" sz="1100" dirty="0"/>
           </a:p>
         </p:txBody>
       </p:sp>
@@ -2680,8 +2680,8 @@
         </p:nvSpPr>
         <p:spPr>
           <a:xfrm>
-            <a:off x="4206240" y="1188720"/>
-            <a:ext cx="1737360" cy="457200"/>
+            <a:off x="4160520" y="1188720"/>
+            <a:ext cx="1828800" cy="457200"/>
           </a:xfrm>
           <a:prstGeom prst="roundRect">
             <a:avLst>
@@ -2702,8 +2702,8 @@
         </p:nvSpPr>
         <p:spPr>
           <a:xfrm>
-            <a:off x="4206240" y="1188720"/>
-            <a:ext cx="1737360" cy="457200"/>
+            <a:off x="4160520" y="1188720"/>
+            <a:ext cx="1828800" cy="457200"/>
           </a:xfrm>
           <a:prstGeom prst="rect">
             <a:avLst/>
@@ -2719,7 +2719,7 @@
               <a:buNone/>
             </a:pPr>
             <a:r>
-              <a:rPr lang="en-US" sz="1250" b="1" dirty="0">
+              <a:rPr lang="en-US" sz="1100" b="1" dirty="0">
                 <a:solidFill>
                   <a:srgbClr val="FFFFFF"/>
                 </a:solidFill>
@@ -2729,7 +2729,7 @@
               </a:rPr>
               <a:t>iOS</a:t>
             </a:r>
-            <a:endParaRPr lang="en-US" sz="1250" dirty="0"/>
+            <a:endParaRPr lang="en-US" sz="1100" dirty="0"/>
           </a:p>
         </p:txBody>
       </p:sp>
@@ -2764,8 +2764,8 @@
         </p:nvSpPr>
         <p:spPr>
           <a:xfrm>
-            <a:off x="6217920" y="1188720"/>
-            <a:ext cx="1737360" cy="457200"/>
+            <a:off x="6172200" y="1188720"/>
+            <a:ext cx="1828800" cy="457200"/>
           </a:xfrm>
           <a:prstGeom prst="roundRect">
             <a:avLst>
@@ -2786,8 +2786,8 @@
         </p:nvSpPr>
         <p:spPr>
           <a:xfrm>
-            <a:off x="6217920" y="1188720"/>
-            <a:ext cx="1737360" cy="457200"/>
+            <a:off x="6172200" y="1188720"/>
+            <a:ext cx="1828800" cy="457200"/>
           </a:xfrm>
           <a:prstGeom prst="rect">
             <a:avLst/>
@@ -2803,7 +2803,7 @@
               <a:buNone/>
             </a:pPr>
             <a:r>
-              <a:rPr lang="en-US" sz="1250" b="1" dirty="0">
+              <a:rPr lang="en-US" sz="1100" b="1" dirty="0">
                 <a:solidFill>
                   <a:srgbClr val="FFFFFF"/>
                 </a:solidFill>
@@ -2813,7 +2813,7 @@
               </a:rPr>
               <a:t>Safari</a:t>
             </a:r>
-            <a:endParaRPr lang="en-US" sz="1250" dirty="0"/>
+            <a:endParaRPr lang="en-US" sz="1100" dirty="0"/>
           </a:p>
         </p:txBody>
       </p:sp>
@@ -2848,8 +2848,8 @@
         </p:nvSpPr>
         <p:spPr>
           <a:xfrm>
-            <a:off x="8229600" y="1188720"/>
-            <a:ext cx="1737360" cy="457200"/>
+            <a:off x="8183880" y="1188720"/>
+            <a:ext cx="1828800" cy="457200"/>
           </a:xfrm>
           <a:prstGeom prst="roundRect">
             <a:avLst>
@@ -2870,8 +2870,8 @@
         </p:nvSpPr>
         <p:spPr>
           <a:xfrm>
-            <a:off x="8229600" y="1188720"/>
-            <a:ext cx="1737360" cy="457200"/>
+            <a:off x="8183880" y="1188720"/>
+            <a:ext cx="1828800" cy="457200"/>
           </a:xfrm>
           <a:prstGeom prst="rect">
             <a:avLst/>
@@ -2887,7 +2887,7 @@
               <a:buNone/>
             </a:pPr>
             <a:r>
-              <a:rPr lang="en-US" sz="1250" b="1" dirty="0">
+              <a:rPr lang="en-US" sz="1100" b="1" dirty="0">
                 <a:solidFill>
                   <a:srgbClr val="FFFFFF"/>
                 </a:solidFill>
@@ -2897,7 +2897,7 @@
               </a:rPr>
               <a:t>Backend</a:t>
             </a:r>
-            <a:endParaRPr lang="en-US" sz="1250" dirty="0"/>
+            <a:endParaRPr lang="en-US" sz="1100" dirty="0"/>
           </a:p>
         </p:txBody>
       </p:sp>
@@ -2932,8 +2932,8 @@
         </p:nvSpPr>
         <p:spPr>
           <a:xfrm>
-            <a:off x="10241280" y="1188720"/>
-            <a:ext cx="1737360" cy="457200"/>
+            <a:off x="10195560" y="1188720"/>
+            <a:ext cx="1828800" cy="457200"/>
           </a:xfrm>
           <a:prstGeom prst="roundRect">
             <a:avLst>
@@ -2941,7 +2941,7 @@
             </a:avLst>
           </a:prstGeom>
           <a:solidFill>
-            <a:srgbClr val="E63946"/>
+            <a:srgbClr val="5B6B79"/>
           </a:solidFill>
           <a:ln/>
         </p:spPr>
@@ -2954,8 +2954,8 @@
         </p:nvSpPr>
         <p:spPr>
           <a:xfrm>
-            <a:off x="10241280" y="1188720"/>
-            <a:ext cx="1737360" cy="457200"/>
+            <a:off x="10195560" y="1188720"/>
+            <a:ext cx="1828800" cy="457200"/>
           </a:xfrm>
           <a:prstGeom prst="rect">
             <a:avLst/>
@@ -2971,7 +2971,7 @@
               <a:buNone/>
             </a:pPr>
             <a:r>
-              <a:rPr lang="en-US" sz="1250" b="1" dirty="0">
+              <a:rPr lang="en-US" sz="1100" b="1" dirty="0">
                 <a:solidFill>
                   <a:srgbClr val="FFFFFF"/>
                 </a:solidFill>
@@ -2979,9 +2979,9 @@
                 <a:ea typeface="Calibri" pitchFamily="34" charset="-122"/>
                 <a:cs typeface="Calibri" pitchFamily="34" charset="-120"/>
               </a:rPr>
-              <a:t>Bank A app</a:t>
-            </a:r>
-            <a:endParaRPr lang="en-US" sz="1250" dirty="0"/>
+              <a:t>Bank X app</a:t>
+            </a:r>
+            <a:endParaRPr lang="en-US" sz="1100" dirty="0"/>
           </a:p>
         </p:txBody>
       </p:sp>
@@ -3041,7 +3041,7 @@
                 <a:ea typeface="Calibri" pitchFamily="34" charset="-122"/>
                 <a:cs typeface="Calibri" pitchFamily="34" charset="-120"/>
               </a:rPr>
-              <a:t>Scan QR code</a:t>
+              <a:t>Scan with Camera — or tap the QR image on a webpage</a:t>
             </a:r>
             <a:endParaRPr lang="en-US" sz="1000" dirty="0"/>
           </a:p>
@@ -3356,7 +3356,7 @@
                 <a:ea typeface="Calibri" pitchFamily="34" charset="-122"/>
                 <a:cs typeface="Calibri" pitchFamily="34" charset="-120"/>
               </a:rPr>
-              <a:t>Tap “Bank A”</a:t>
+              <a:t>Tap one bank (A, B, or C)</a:t>
             </a:r>
             <a:endParaRPr lang="en-US" sz="1000" dirty="0"/>
           </a:p>
@@ -3419,7 +3419,7 @@
                 <a:ea typeface="Calibri" pitchFamily="34" charset="-122"/>
                 <a:cs typeface="Calibri" pitchFamily="34" charset="-120"/>
               </a:rPr>
-              <a:t>Navigate bankademo://pay?token=…</a:t>
+              <a:t>Navigate bank&lt;x&gt;demo://pay?token=…</a:t>
             </a:r>
             <a:endParaRPr lang="en-US" sz="1000" dirty="0"/>
           </a:p>
@@ -3482,7 +3482,7 @@
                 <a:ea typeface="Calibri" pitchFamily="34" charset="-122"/>
                 <a:cs typeface="Calibri" pitchFamily="34" charset="-120"/>
               </a:rPr>
-              <a:t>“Open in ‘Bank A’?” system prompt</a:t>
+              <a:t>“Open in ‘Bank X’?” system prompt</a:t>
             </a:r>
             <a:endParaRPr lang="en-US" sz="1000" dirty="0"/>
           </a:p>
@@ -3608,7 +3608,7 @@
                 <a:ea typeface="Calibri" pitchFamily="34" charset="-122"/>
                 <a:cs typeface="Calibri" pitchFamily="34" charset="-120"/>
               </a:rPr>
-              <a:t>Launch Bank A with the link</a:t>
+              <a:t>Launch chosen bank with the link</a:t>
             </a:r>
             <a:endParaRPr lang="en-US" sz="1000" dirty="0"/>
           </a:p>
@@ -3882,8 +3882,8 @@
         </p:nvSpPr>
         <p:spPr>
           <a:xfrm>
-            <a:off x="960120" y="1188720"/>
-            <a:ext cx="1737360" cy="457200"/>
+            <a:off x="914400" y="1188720"/>
+            <a:ext cx="1828800" cy="457200"/>
           </a:xfrm>
           <a:prstGeom prst="roundRect">
             <a:avLst>
@@ -3904,8 +3904,8 @@
         </p:nvSpPr>
         <p:spPr>
           <a:xfrm>
-            <a:off x="960120" y="1188720"/>
-            <a:ext cx="1737360" cy="457200"/>
+            <a:off x="914400" y="1188720"/>
+            <a:ext cx="1828800" cy="457200"/>
           </a:xfrm>
           <a:prstGeom prst="rect">
             <a:avLst/>
@@ -3921,7 +3921,7 @@
               <a:buNone/>
             </a:pPr>
             <a:r>
-              <a:rPr lang="en-US" sz="1250" b="1" dirty="0">
+              <a:rPr lang="en-US" sz="1100" b="1" dirty="0">
                 <a:solidFill>
                   <a:srgbClr val="FFFFFF"/>
                 </a:solidFill>
@@ -3931,7 +3931,7 @@
               </a:rPr>
               <a:t>User</a:t>
             </a:r>
-            <a:endParaRPr lang="en-US" sz="1250" dirty="0"/>
+            <a:endParaRPr lang="en-US" sz="1100" dirty="0"/>
           </a:p>
         </p:txBody>
       </p:sp>
@@ -3966,8 +3966,8 @@
         </p:nvSpPr>
         <p:spPr>
           <a:xfrm>
-            <a:off x="3794760" y="1188720"/>
-            <a:ext cx="1737360" cy="457200"/>
+            <a:off x="3749040" y="1188720"/>
+            <a:ext cx="1828800" cy="457200"/>
           </a:xfrm>
           <a:prstGeom prst="roundRect">
             <a:avLst>
@@ -3988,8 +3988,8 @@
         </p:nvSpPr>
         <p:spPr>
           <a:xfrm>
-            <a:off x="3794760" y="1188720"/>
-            <a:ext cx="1737360" cy="457200"/>
+            <a:off x="3749040" y="1188720"/>
+            <a:ext cx="1828800" cy="457200"/>
           </a:xfrm>
           <a:prstGeom prst="rect">
             <a:avLst/>
@@ -4005,7 +4005,7 @@
               <a:buNone/>
             </a:pPr>
             <a:r>
-              <a:rPr lang="en-US" sz="1250" b="1" dirty="0">
+              <a:rPr lang="en-US" sz="1100" b="1" dirty="0">
                 <a:solidFill>
                   <a:srgbClr val="FFFFFF"/>
                 </a:solidFill>
@@ -4015,7 +4015,7 @@
               </a:rPr>
               <a:t>Bank A app</a:t>
             </a:r>
-            <a:endParaRPr lang="en-US" sz="1250" dirty="0"/>
+            <a:endParaRPr lang="en-US" sz="1100" dirty="0"/>
           </a:p>
         </p:txBody>
       </p:sp>
@@ -4050,8 +4050,8 @@
         </p:nvSpPr>
         <p:spPr>
           <a:xfrm>
-            <a:off x="6629400" y="1188720"/>
-            <a:ext cx="1737360" cy="457200"/>
+            <a:off x="6583680" y="1188720"/>
+            <a:ext cx="1828800" cy="457200"/>
           </a:xfrm>
           <a:prstGeom prst="roundRect">
             <a:avLst>
@@ -4072,8 +4072,8 @@
         </p:nvSpPr>
         <p:spPr>
           <a:xfrm>
-            <a:off x="6629400" y="1188720"/>
-            <a:ext cx="1737360" cy="457200"/>
+            <a:off x="6583680" y="1188720"/>
+            <a:ext cx="1828800" cy="457200"/>
           </a:xfrm>
           <a:prstGeom prst="rect">
             <a:avLst/>
@@ -4089,7 +4089,7 @@
               <a:buNone/>
             </a:pPr>
             <a:r>
-              <a:rPr lang="en-US" sz="1250" b="1" dirty="0">
+              <a:rPr lang="en-US" sz="1100" b="1" dirty="0">
                 <a:solidFill>
                   <a:srgbClr val="FFFFFF"/>
                 </a:solidFill>
@@ -4099,7 +4099,7 @@
               </a:rPr>
               <a:t>Backend</a:t>
             </a:r>
-            <a:endParaRPr lang="en-US" sz="1250" dirty="0"/>
+            <a:endParaRPr lang="en-US" sz="1100" dirty="0"/>
           </a:p>
         </p:txBody>
       </p:sp>
@@ -4134,8 +4134,8 @@
         </p:nvSpPr>
         <p:spPr>
           <a:xfrm>
-            <a:off x="9464040" y="1188720"/>
-            <a:ext cx="1737360" cy="457200"/>
+            <a:off x="9418320" y="1188720"/>
+            <a:ext cx="1828800" cy="457200"/>
           </a:xfrm>
           <a:prstGeom prst="roundRect">
             <a:avLst>
@@ -4156,8 +4156,8 @@
         </p:nvSpPr>
         <p:spPr>
           <a:xfrm>
-            <a:off x="9464040" y="1188720"/>
-            <a:ext cx="1737360" cy="457200"/>
+            <a:off x="9418320" y="1188720"/>
+            <a:ext cx="1828800" cy="457200"/>
           </a:xfrm>
           <a:prstGeom prst="rect">
             <a:avLst/>
@@ -4173,7 +4173,7 @@
               <a:buNone/>
             </a:pPr>
             <a:r>
-              <a:rPr lang="en-US" sz="1250" b="1" dirty="0">
+              <a:rPr lang="en-US" sz="1100" b="1" dirty="0">
                 <a:solidFill>
                   <a:srgbClr val="FFFFFF"/>
                 </a:solidFill>
@@ -4183,7 +4183,7 @@
               </a:rPr>
               <a:t>Bank B app</a:t>
             </a:r>
-            <a:endParaRPr lang="en-US" sz="1250" dirty="0"/>
+            <a:endParaRPr lang="en-US" sz="1100" dirty="0"/>
           </a:p>
         </p:txBody>
       </p:sp>

</xml_diff>

<commit_message>
Add side-by-side user journey comparison slide
Shows Android and iOS as parallel 5-step lanes with connectors marking
each step "same" or "differs" — makes explicit that only step 3 (how
you pick a bank) actually diverges between platforms.
</commit_message>
<xml_diff>
--- a/SGQR_Sequence_Diagrams.pptx
+++ b/SGQR_Sequence_Diagrams.pptx
@@ -8,9 +8,10 @@
     <p:sldId id="256" r:id="rId2"/>
     <p:sldId id="257" r:id="rId3"/>
     <p:sldId id="258" r:id="rId4"/>
+    <p:sldId id="259" r:id="rId5"/>
   </p:sldIdLst>
   <p:notesMasterIdLst>
-    <p:notesMasterId r:id="rId5"/>
+    <p:notesMasterId r:id="rId6"/>
   </p:notesMasterIdLst>
   <p:sldSz cx="12192000" cy="6858000"/>
   <p:notesSz cx="6858000" cy="12192000"/>
@@ -704,6 +705,94 @@
             <a:fld id="{F7021451-1387-4CA6-816F-3879F97B5CBC}" type="slidenum">
               <a:rPr lang="en-US"/>
               <a:t>3</a:t>
+            </a:fld>
+            <a:endParaRPr lang="en-US"/>
+          </a:p>
+        </p:txBody>
+      </p:sp>
+    </p:spTree>
+    <p:extLst>
+      <p:ext uri="{BB962C8B-B14F-4D97-AF65-F5344CB8AC3E}">
+        <p14:creationId xmlns:p14="http://schemas.microsoft.com/office/powerpoint/2010/main" val="1024086991"/>
+      </p:ext>
+    </p:extLst>
+  </p:cSld>
+  <p:clrMapOvr>
+    <a:masterClrMapping/>
+  </p:clrMapOvr>
+</p:notes>
+</file>
+
+<file path=ppt/notesSlides/notesSlide4.xml><?xml version="1.0" encoding="utf-8"?>
+<p:notes xmlns:a="http://schemas.openxmlformats.org/drawingml/2006/main" xmlns:r="http://schemas.openxmlformats.org/officeDocument/2006/relationships" xmlns:p="http://schemas.openxmlformats.org/presentationml/2006/main">
+  <p:cSld>
+    <p:spTree>
+      <p:nvGrpSpPr>
+        <p:cNvPr id="1" name=""/>
+        <p:cNvGrpSpPr/>
+        <p:nvPr/>
+      </p:nvGrpSpPr>
+      <p:grpSpPr>
+        <a:xfrm>
+          <a:off x="0" y="0"/>
+          <a:ext cx="0" cy="0"/>
+          <a:chOff x="0" y="0"/>
+          <a:chExt cx="0" cy="0"/>
+        </a:xfrm>
+      </p:grpSpPr>
+      <p:sp>
+        <p:nvSpPr>
+          <p:cNvPr id="2" name="Slide Image Placeholder 1"/>
+          <p:cNvSpPr>
+            <a:spLocks noGrp="1" noRot="1" noChangeAspect="1"/>
+          </p:cNvSpPr>
+          <p:nvPr>
+            <p:ph type="sldImg"/>
+          </p:nvPr>
+        </p:nvSpPr>
+        <p:spPr/>
+      </p:sp>
+      <p:sp>
+        <p:nvSpPr>
+          <p:cNvPr id="3" name="Notes Placeholder 2"/>
+          <p:cNvSpPr>
+            <a:spLocks noGrp="1"/>
+          </p:cNvSpPr>
+          <p:nvPr>
+            <p:ph type="body" idx="1"/>
+          </p:nvPr>
+        </p:nvSpPr>
+        <p:spPr/>
+        <p:txBody>
+          <a:bodyPr/>
+          <a:lstStyle/>
+          <a:p>
+            <a:r>
+              <a:rPr lang="en-US" dirty="0"/>
+              <a:t/>
+            </a:r>
+            <a:endParaRPr lang="en-US" dirty="0"/>
+          </a:p>
+        </p:txBody>
+      </p:sp>
+      <p:sp>
+        <p:nvSpPr>
+          <p:cNvPr id="4" name="Slide Number Placeholder 3"/>
+          <p:cNvSpPr>
+            <a:spLocks noGrp="1"/>
+          </p:cNvSpPr>
+          <p:nvPr>
+            <p:ph type="sldNum" sz="quarter" idx="10"/>
+          </p:nvPr>
+        </p:nvSpPr>
+        <p:spPr/>
+        <p:txBody>
+          <a:bodyPr/>
+          <a:lstStyle/>
+          <a:p>
+            <a:fld id="{F7021451-1387-4CA6-816F-3879F97B5CBC}" type="slidenum">
+              <a:rPr lang="en-US"/>
+              <a:t>4</a:t>
             </a:fld>
             <a:endParaRPr lang="en-US"/>
           </a:p>
@@ -4860,6 +4949,1907 @@
 </p:sld>
 </file>
 
+<file path=ppt/slides/slide4.xml><?xml version="1.0" encoding="utf-8"?>
+<p:sld xmlns:a="http://schemas.openxmlformats.org/drawingml/2006/main" xmlns:r="http://schemas.openxmlformats.org/officeDocument/2006/relationships" xmlns:p="http://schemas.openxmlformats.org/presentationml/2006/main">
+  <p:cSld name="Slide 4">
+    <p:bg>
+      <p:bgPr>
+        <a:solidFill>
+          <a:srgbClr val="F5F8FA"/>
+        </a:solidFill>
+      </p:bgPr>
+    </p:bg>
+    <p:spTree>
+      <p:nvGrpSpPr>
+        <p:cNvPr id="1" name=""/>
+        <p:cNvGrpSpPr/>
+        <p:nvPr/>
+      </p:nvGrpSpPr>
+      <p:grpSpPr>
+        <a:xfrm>
+          <a:off x="0" y="0"/>
+          <a:ext cx="0" cy="0"/>
+          <a:chOff x="0" y="0"/>
+          <a:chExt cx="0" cy="0"/>
+        </a:xfrm>
+      </p:grpSpPr>
+      <p:sp>
+        <p:nvSpPr>
+          <p:cNvPr id="2" name="Text 0"/>
+          <p:cNvSpPr/>
+          <p:nvPr/>
+        </p:nvSpPr>
+        <p:spPr>
+          <a:xfrm>
+            <a:off x="548640" y="274320"/>
+            <a:ext cx="11064240" cy="457200"/>
+          </a:xfrm>
+          <a:prstGeom prst="rect">
+            <a:avLst/>
+          </a:prstGeom>
+          <a:noFill/>
+          <a:ln/>
+        </p:spPr>
+        <p:txBody>
+          <a:bodyPr wrap="square" lIns="0" tIns="0" rIns="0" bIns="0" rtlCol="0" anchor="ctr"/>
+          <a:lstStyle/>
+          <a:p>
+            <a:pPr indent="0" marL="0">
+              <a:buNone/>
+            </a:pPr>
+            <a:r>
+              <a:rPr lang="en-US" sz="2600" b="1" dirty="0">
+                <a:solidFill>
+                  <a:srgbClr val="1A2233"/>
+                </a:solidFill>
+                <a:latin typeface="Cambria" pitchFamily="34" charset="0"/>
+                <a:ea typeface="Cambria" pitchFamily="34" charset="-122"/>
+                <a:cs typeface="Cambria" pitchFamily="34" charset="-120"/>
+              </a:rPr>
+              <a:t>One user journey, two platforms</a:t>
+            </a:r>
+            <a:endParaRPr lang="en-US" sz="2600" dirty="0"/>
+          </a:p>
+        </p:txBody>
+      </p:sp>
+      <p:sp>
+        <p:nvSpPr>
+          <p:cNvPr id="3" name="Text 1"/>
+          <p:cNvSpPr/>
+          <p:nvPr/>
+        </p:nvSpPr>
+        <p:spPr>
+          <a:xfrm>
+            <a:off x="548640" y="758952"/>
+            <a:ext cx="11064240" cy="320040"/>
+          </a:xfrm>
+          <a:prstGeom prst="rect">
+            <a:avLst/>
+          </a:prstGeom>
+          <a:noFill/>
+          <a:ln/>
+        </p:spPr>
+        <p:txBody>
+          <a:bodyPr wrap="square" lIns="0" tIns="0" rIns="0" bIns="0" rtlCol="0" anchor="ctr"/>
+          <a:lstStyle/>
+          <a:p>
+            <a:pPr indent="0" marL="0">
+              <a:buNone/>
+            </a:pPr>
+            <a:r>
+              <a:rPr lang="en-US" sz="1250" dirty="0">
+                <a:solidFill>
+                  <a:srgbClr val="5B6B79"/>
+                </a:solidFill>
+                <a:latin typeface="Calibri" pitchFamily="34" charset="0"/>
+                <a:ea typeface="Calibri" pitchFamily="34" charset="-122"/>
+                <a:cs typeface="Calibri" pitchFamily="34" charset="-120"/>
+              </a:rPr>
+              <a:t>4 of 5 steps are identical on Android and iOS — only how you pick a bank differs</a:t>
+            </a:r>
+            <a:endParaRPr lang="en-US" sz="1250" dirty="0"/>
+          </a:p>
+        </p:txBody>
+      </p:sp>
+      <p:sp>
+        <p:nvSpPr>
+          <p:cNvPr id="4" name="Shape 2"/>
+          <p:cNvSpPr/>
+          <p:nvPr/>
+        </p:nvSpPr>
+        <p:spPr>
+          <a:xfrm>
+            <a:off x="137160" y="1828800"/>
+            <a:ext cx="777240" cy="1234440"/>
+          </a:xfrm>
+          <a:prstGeom prst="roundRect">
+            <a:avLst>
+              <a:gd name="adj" fmla="val 9412"/>
+            </a:avLst>
+          </a:prstGeom>
+          <a:solidFill>
+            <a:srgbClr val="065A82"/>
+          </a:solidFill>
+          <a:ln/>
+        </p:spPr>
+      </p:sp>
+      <p:sp>
+        <p:nvSpPr>
+          <p:cNvPr id="5" name="Text 3"/>
+          <p:cNvSpPr/>
+          <p:nvPr/>
+        </p:nvSpPr>
+        <p:spPr>
+          <a:xfrm>
+            <a:off x="91440" y="1828800"/>
+            <a:ext cx="868680" cy="1234440"/>
+          </a:xfrm>
+          <a:prstGeom prst="rect">
+            <a:avLst/>
+          </a:prstGeom>
+          <a:noFill/>
+          <a:ln/>
+        </p:spPr>
+        <p:txBody>
+          <a:bodyPr wrap="square" lIns="0" tIns="0" rIns="0" bIns="0" rtlCol="0" anchor="ctr"/>
+          <a:lstStyle/>
+          <a:p>
+            <a:pPr algn="ctr" indent="0" marL="0">
+              <a:buNone/>
+            </a:pPr>
+            <a:r>
+              <a:rPr lang="en-US" sz="1150" b="1" dirty="0">
+                <a:solidFill>
+                  <a:srgbClr val="FFFFFF"/>
+                </a:solidFill>
+                <a:latin typeface="Calibri" pitchFamily="34" charset="0"/>
+                <a:ea typeface="Calibri" pitchFamily="34" charset="-122"/>
+                <a:cs typeface="Calibri" pitchFamily="34" charset="-120"/>
+              </a:rPr>
+              <a:t>Android</a:t>
+            </a:r>
+            <a:endParaRPr lang="en-US" sz="1150" dirty="0"/>
+          </a:p>
+        </p:txBody>
+      </p:sp>
+      <p:sp>
+        <p:nvSpPr>
+          <p:cNvPr id="6" name="Shape 4"/>
+          <p:cNvSpPr/>
+          <p:nvPr/>
+        </p:nvSpPr>
+        <p:spPr>
+          <a:xfrm>
+            <a:off x="137160" y="4434840"/>
+            <a:ext cx="777240" cy="1234440"/>
+          </a:xfrm>
+          <a:prstGeom prst="roundRect">
+            <a:avLst>
+              <a:gd name="adj" fmla="val 9412"/>
+            </a:avLst>
+          </a:prstGeom>
+          <a:solidFill>
+            <a:srgbClr val="1C7293"/>
+          </a:solidFill>
+          <a:ln/>
+        </p:spPr>
+      </p:sp>
+      <p:sp>
+        <p:nvSpPr>
+          <p:cNvPr id="7" name="Text 5"/>
+          <p:cNvSpPr/>
+          <p:nvPr/>
+        </p:nvSpPr>
+        <p:spPr>
+          <a:xfrm>
+            <a:off x="137160" y="4434840"/>
+            <a:ext cx="777240" cy="1234440"/>
+          </a:xfrm>
+          <a:prstGeom prst="rect">
+            <a:avLst/>
+          </a:prstGeom>
+          <a:noFill/>
+          <a:ln/>
+        </p:spPr>
+        <p:txBody>
+          <a:bodyPr wrap="square" lIns="0" tIns="0" rIns="0" bIns="0" rtlCol="0" anchor="ctr"/>
+          <a:lstStyle/>
+          <a:p>
+            <a:pPr algn="ctr" indent="0" marL="0">
+              <a:buNone/>
+            </a:pPr>
+            <a:r>
+              <a:rPr lang="en-US" sz="1250" b="1" dirty="0">
+                <a:solidFill>
+                  <a:srgbClr val="FFFFFF"/>
+                </a:solidFill>
+                <a:latin typeface="Calibri" pitchFamily="34" charset="0"/>
+                <a:ea typeface="Calibri" pitchFamily="34" charset="-122"/>
+                <a:cs typeface="Calibri" pitchFamily="34" charset="-120"/>
+              </a:rPr>
+              <a:t>iOS</a:t>
+            </a:r>
+            <a:endParaRPr lang="en-US" sz="1250" dirty="0"/>
+          </a:p>
+        </p:txBody>
+      </p:sp>
+      <p:sp>
+        <p:nvSpPr>
+          <p:cNvPr id="8" name="Shape 6"/>
+          <p:cNvSpPr/>
+          <p:nvPr/>
+        </p:nvSpPr>
+        <p:spPr>
+          <a:xfrm>
+            <a:off x="1847088" y="1517904"/>
+            <a:ext cx="329184" cy="329184"/>
+          </a:xfrm>
+          <a:prstGeom prst="ellipse">
+            <a:avLst/>
+          </a:prstGeom>
+          <a:solidFill>
+            <a:srgbClr val="1A2233"/>
+          </a:solidFill>
+          <a:ln/>
+        </p:spPr>
+      </p:sp>
+      <p:sp>
+        <p:nvSpPr>
+          <p:cNvPr id="9" name="Text 7"/>
+          <p:cNvSpPr/>
+          <p:nvPr/>
+        </p:nvSpPr>
+        <p:spPr>
+          <a:xfrm>
+            <a:off x="1847088" y="1517904"/>
+            <a:ext cx="329184" cy="329184"/>
+          </a:xfrm>
+          <a:prstGeom prst="rect">
+            <a:avLst/>
+          </a:prstGeom>
+          <a:noFill/>
+          <a:ln/>
+        </p:spPr>
+        <p:txBody>
+          <a:bodyPr wrap="square" lIns="0" tIns="0" rIns="0" bIns="0" rtlCol="0" anchor="ctr"/>
+          <a:lstStyle/>
+          <a:p>
+            <a:pPr algn="ctr" indent="0" marL="0">
+              <a:buNone/>
+            </a:pPr>
+            <a:r>
+              <a:rPr lang="en-US" sz="1200" b="1" dirty="0">
+                <a:solidFill>
+                  <a:srgbClr val="FFFFFF"/>
+                </a:solidFill>
+                <a:latin typeface="Calibri" pitchFamily="34" charset="0"/>
+                <a:ea typeface="Calibri" pitchFamily="34" charset="-122"/>
+                <a:cs typeface="Calibri" pitchFamily="34" charset="-120"/>
+              </a:rPr>
+              <a:t>1</a:t>
+            </a:r>
+            <a:endParaRPr lang="en-US" sz="1200" dirty="0"/>
+          </a:p>
+        </p:txBody>
+      </p:sp>
+      <p:sp>
+        <p:nvSpPr>
+          <p:cNvPr id="10" name="Shape 8"/>
+          <p:cNvSpPr/>
+          <p:nvPr/>
+        </p:nvSpPr>
+        <p:spPr>
+          <a:xfrm>
+            <a:off x="1097280" y="1828800"/>
+            <a:ext cx="1828800" cy="1234440"/>
+          </a:xfrm>
+          <a:prstGeom prst="roundRect">
+            <a:avLst>
+              <a:gd name="adj" fmla="val 5926"/>
+            </a:avLst>
+          </a:prstGeom>
+          <a:solidFill>
+            <a:srgbClr val="FFFFFF"/>
+          </a:solidFill>
+          <a:ln w="12700">
+            <a:solidFill>
+              <a:srgbClr val="D7DEE5"/>
+            </a:solidFill>
+            <a:prstDash val="solid"/>
+          </a:ln>
+        </p:spPr>
+      </p:sp>
+      <p:sp>
+        <p:nvSpPr>
+          <p:cNvPr id="11" name="Text 9"/>
+          <p:cNvSpPr/>
+          <p:nvPr/>
+        </p:nvSpPr>
+        <p:spPr>
+          <a:xfrm>
+            <a:off x="1207008" y="1828800"/>
+            <a:ext cx="1609344" cy="1234440"/>
+          </a:xfrm>
+          <a:prstGeom prst="rect">
+            <a:avLst/>
+          </a:prstGeom>
+          <a:noFill/>
+          <a:ln/>
+        </p:spPr>
+        <p:txBody>
+          <a:bodyPr wrap="square" lIns="0" tIns="0" rIns="0" bIns="0" rtlCol="0" anchor="ctr"/>
+          <a:lstStyle/>
+          <a:p>
+            <a:pPr algn="ctr" indent="0" marL="0">
+              <a:lnSpc>
+                <a:spcPct val="115000"/>
+              </a:lnSpc>
+              <a:buNone/>
+            </a:pPr>
+            <a:r>
+              <a:rPr lang="en-US" sz="1150" dirty="0">
+                <a:solidFill>
+                  <a:srgbClr val="1A2233"/>
+                </a:solidFill>
+                <a:latin typeface="Calibri" pitchFamily="34" charset="0"/>
+                <a:ea typeface="Calibri" pitchFamily="34" charset="-122"/>
+                <a:cs typeface="Calibri" pitchFamily="34" charset="-120"/>
+              </a:rPr>
+              <a:t>Scan with Camera —</a:t>
+            </a:r>
+            <a:endParaRPr lang="en-US" sz="1150" dirty="0"/>
+          </a:p>
+          <a:p>
+            <a:pPr algn="ctr" indent="0" marL="0">
+              <a:lnSpc>
+                <a:spcPct val="115000"/>
+              </a:lnSpc>
+              <a:buNone/>
+            </a:pPr>
+            <a:r>
+              <a:rPr lang="en-US" sz="1150" dirty="0">
+                <a:solidFill>
+                  <a:srgbClr val="1A2233"/>
+                </a:solidFill>
+                <a:latin typeface="Calibri" pitchFamily="34" charset="0"/>
+                <a:ea typeface="Calibri" pitchFamily="34" charset="-122"/>
+                <a:cs typeface="Calibri" pitchFamily="34" charset="-120"/>
+              </a:rPr>
+              <a:t>or tap the QR image</a:t>
+            </a:r>
+            <a:endParaRPr lang="en-US" sz="1150" dirty="0"/>
+          </a:p>
+        </p:txBody>
+      </p:sp>
+      <p:sp>
+        <p:nvSpPr>
+          <p:cNvPr id="12" name="Shape 10"/>
+          <p:cNvSpPr/>
+          <p:nvPr/>
+        </p:nvSpPr>
+        <p:spPr>
+          <a:xfrm>
+            <a:off x="1097280" y="4434840"/>
+            <a:ext cx="1828800" cy="1234440"/>
+          </a:xfrm>
+          <a:prstGeom prst="roundRect">
+            <a:avLst>
+              <a:gd name="adj" fmla="val 5926"/>
+            </a:avLst>
+          </a:prstGeom>
+          <a:solidFill>
+            <a:srgbClr val="FFFFFF"/>
+          </a:solidFill>
+          <a:ln w="12700">
+            <a:solidFill>
+              <a:srgbClr val="D7DEE5"/>
+            </a:solidFill>
+            <a:prstDash val="solid"/>
+          </a:ln>
+        </p:spPr>
+      </p:sp>
+      <p:sp>
+        <p:nvSpPr>
+          <p:cNvPr id="13" name="Text 11"/>
+          <p:cNvSpPr/>
+          <p:nvPr/>
+        </p:nvSpPr>
+        <p:spPr>
+          <a:xfrm>
+            <a:off x="1207008" y="4434840"/>
+            <a:ext cx="1609344" cy="1234440"/>
+          </a:xfrm>
+          <a:prstGeom prst="rect">
+            <a:avLst/>
+          </a:prstGeom>
+          <a:noFill/>
+          <a:ln/>
+        </p:spPr>
+        <p:txBody>
+          <a:bodyPr wrap="square" lIns="0" tIns="0" rIns="0" bIns="0" rtlCol="0" anchor="ctr"/>
+          <a:lstStyle/>
+          <a:p>
+            <a:pPr algn="ctr" indent="0" marL="0">
+              <a:lnSpc>
+                <a:spcPct val="115000"/>
+              </a:lnSpc>
+              <a:buNone/>
+            </a:pPr>
+            <a:r>
+              <a:rPr lang="en-US" sz="1150" dirty="0">
+                <a:solidFill>
+                  <a:srgbClr val="1A2233"/>
+                </a:solidFill>
+                <a:latin typeface="Calibri" pitchFamily="34" charset="0"/>
+                <a:ea typeface="Calibri" pitchFamily="34" charset="-122"/>
+                <a:cs typeface="Calibri" pitchFamily="34" charset="-120"/>
+              </a:rPr>
+              <a:t>Scan with Camera —</a:t>
+            </a:r>
+            <a:endParaRPr lang="en-US" sz="1150" dirty="0"/>
+          </a:p>
+          <a:p>
+            <a:pPr algn="ctr" indent="0" marL="0">
+              <a:lnSpc>
+                <a:spcPct val="115000"/>
+              </a:lnSpc>
+              <a:buNone/>
+            </a:pPr>
+            <a:r>
+              <a:rPr lang="en-US" sz="1150" dirty="0">
+                <a:solidFill>
+                  <a:srgbClr val="1A2233"/>
+                </a:solidFill>
+                <a:latin typeface="Calibri" pitchFamily="34" charset="0"/>
+                <a:ea typeface="Calibri" pitchFamily="34" charset="-122"/>
+                <a:cs typeface="Calibri" pitchFamily="34" charset="-120"/>
+              </a:rPr>
+              <a:t>or tap the QR image</a:t>
+            </a:r>
+            <a:endParaRPr lang="en-US" sz="1150" dirty="0"/>
+          </a:p>
+        </p:txBody>
+      </p:sp>
+      <p:sp>
+        <p:nvSpPr>
+          <p:cNvPr id="14" name="Shape 12"/>
+          <p:cNvSpPr/>
+          <p:nvPr/>
+        </p:nvSpPr>
+        <p:spPr>
+          <a:xfrm>
+            <a:off x="2011680" y="3063240"/>
+            <a:ext cx="0" cy="1371600"/>
+          </a:xfrm>
+          <a:prstGeom prst="line">
+            <a:avLst/>
+          </a:prstGeom>
+          <a:noFill/>
+          <a:ln w="19050">
+            <a:solidFill>
+              <a:srgbClr val="8FD6C4"/>
+            </a:solidFill>
+            <a:prstDash val="solid"/>
+          </a:ln>
+        </p:spPr>
+      </p:sp>
+      <p:sp>
+        <p:nvSpPr>
+          <p:cNvPr id="15" name="Shape 13"/>
+          <p:cNvSpPr/>
+          <p:nvPr/>
+        </p:nvSpPr>
+        <p:spPr>
+          <a:xfrm>
+            <a:off x="1531620" y="3602736"/>
+            <a:ext cx="960120" cy="292608"/>
+          </a:xfrm>
+          <a:prstGeom prst="roundRect">
+            <a:avLst>
+              <a:gd name="adj" fmla="val 50000"/>
+            </a:avLst>
+          </a:prstGeom>
+          <a:solidFill>
+            <a:srgbClr val="5EEAD4"/>
+          </a:solidFill>
+          <a:ln/>
+        </p:spPr>
+      </p:sp>
+      <p:sp>
+        <p:nvSpPr>
+          <p:cNvPr id="16" name="Text 14"/>
+          <p:cNvSpPr/>
+          <p:nvPr/>
+        </p:nvSpPr>
+        <p:spPr>
+          <a:xfrm>
+            <a:off x="1531620" y="3602736"/>
+            <a:ext cx="960120" cy="292608"/>
+          </a:xfrm>
+          <a:prstGeom prst="rect">
+            <a:avLst/>
+          </a:prstGeom>
+          <a:noFill/>
+          <a:ln/>
+        </p:spPr>
+        <p:txBody>
+          <a:bodyPr wrap="square" lIns="0" tIns="0" rIns="0" bIns="0" rtlCol="0" anchor="ctr"/>
+          <a:lstStyle/>
+          <a:p>
+            <a:pPr algn="ctr" indent="0" marL="0">
+              <a:buNone/>
+            </a:pPr>
+            <a:r>
+              <a:rPr lang="en-US" sz="1000" b="1" dirty="0">
+                <a:solidFill>
+                  <a:srgbClr val="0B3B44"/>
+                </a:solidFill>
+                <a:latin typeface="Calibri" pitchFamily="34" charset="0"/>
+                <a:ea typeface="Calibri" pitchFamily="34" charset="-122"/>
+                <a:cs typeface="Calibri" pitchFamily="34" charset="-120"/>
+              </a:rPr>
+              <a:t>same</a:t>
+            </a:r>
+            <a:endParaRPr lang="en-US" sz="1000" dirty="0"/>
+          </a:p>
+        </p:txBody>
+      </p:sp>
+      <p:sp>
+        <p:nvSpPr>
+          <p:cNvPr id="17" name="Shape 15"/>
+          <p:cNvSpPr/>
+          <p:nvPr/>
+        </p:nvSpPr>
+        <p:spPr>
+          <a:xfrm>
+            <a:off x="3931920" y="1517904"/>
+            <a:ext cx="329184" cy="329184"/>
+          </a:xfrm>
+          <a:prstGeom prst="ellipse">
+            <a:avLst/>
+          </a:prstGeom>
+          <a:solidFill>
+            <a:srgbClr val="1A2233"/>
+          </a:solidFill>
+          <a:ln/>
+        </p:spPr>
+      </p:sp>
+      <p:sp>
+        <p:nvSpPr>
+          <p:cNvPr id="18" name="Text 16"/>
+          <p:cNvSpPr/>
+          <p:nvPr/>
+        </p:nvSpPr>
+        <p:spPr>
+          <a:xfrm>
+            <a:off x="3931920" y="1517904"/>
+            <a:ext cx="329184" cy="329184"/>
+          </a:xfrm>
+          <a:prstGeom prst="rect">
+            <a:avLst/>
+          </a:prstGeom>
+          <a:noFill/>
+          <a:ln/>
+        </p:spPr>
+        <p:txBody>
+          <a:bodyPr wrap="square" lIns="0" tIns="0" rIns="0" bIns="0" rtlCol="0" anchor="ctr"/>
+          <a:lstStyle/>
+          <a:p>
+            <a:pPr algn="ctr" indent="0" marL="0">
+              <a:buNone/>
+            </a:pPr>
+            <a:r>
+              <a:rPr lang="en-US" sz="1200" b="1" dirty="0">
+                <a:solidFill>
+                  <a:srgbClr val="FFFFFF"/>
+                </a:solidFill>
+                <a:latin typeface="Calibri" pitchFamily="34" charset="0"/>
+                <a:ea typeface="Calibri" pitchFamily="34" charset="-122"/>
+                <a:cs typeface="Calibri" pitchFamily="34" charset="-120"/>
+              </a:rPr>
+              <a:t>2</a:t>
+            </a:r>
+            <a:endParaRPr lang="en-US" sz="1200" dirty="0"/>
+          </a:p>
+        </p:txBody>
+      </p:sp>
+      <p:sp>
+        <p:nvSpPr>
+          <p:cNvPr id="19" name="Shape 17"/>
+          <p:cNvSpPr/>
+          <p:nvPr/>
+        </p:nvSpPr>
+        <p:spPr>
+          <a:xfrm>
+            <a:off x="3182112" y="1828800"/>
+            <a:ext cx="1828800" cy="1234440"/>
+          </a:xfrm>
+          <a:prstGeom prst="roundRect">
+            <a:avLst>
+              <a:gd name="adj" fmla="val 5926"/>
+            </a:avLst>
+          </a:prstGeom>
+          <a:solidFill>
+            <a:srgbClr val="FFFFFF"/>
+          </a:solidFill>
+          <a:ln w="12700">
+            <a:solidFill>
+              <a:srgbClr val="D7DEE5"/>
+            </a:solidFill>
+            <a:prstDash val="solid"/>
+          </a:ln>
+        </p:spPr>
+      </p:sp>
+      <p:sp>
+        <p:nvSpPr>
+          <p:cNvPr id="20" name="Text 18"/>
+          <p:cNvSpPr/>
+          <p:nvPr/>
+        </p:nvSpPr>
+        <p:spPr>
+          <a:xfrm>
+            <a:off x="3291840" y="1828800"/>
+            <a:ext cx="1609344" cy="1234440"/>
+          </a:xfrm>
+          <a:prstGeom prst="rect">
+            <a:avLst/>
+          </a:prstGeom>
+          <a:noFill/>
+          <a:ln/>
+        </p:spPr>
+        <p:txBody>
+          <a:bodyPr wrap="square" lIns="0" tIns="0" rIns="0" bIns="0" rtlCol="0" anchor="ctr"/>
+          <a:lstStyle/>
+          <a:p>
+            <a:pPr algn="ctr" indent="0" marL="0">
+              <a:lnSpc>
+                <a:spcPct val="115000"/>
+              </a:lnSpc>
+              <a:buNone/>
+            </a:pPr>
+            <a:r>
+              <a:rPr lang="en-US" sz="1150" dirty="0">
+                <a:solidFill>
+                  <a:srgbClr val="1A2233"/>
+                </a:solidFill>
+                <a:latin typeface="Calibri" pitchFamily="34" charset="0"/>
+                <a:ea typeface="Calibri" pitchFamily="34" charset="-122"/>
+                <a:cs typeface="Calibri" pitchFamily="34" charset="-120"/>
+              </a:rPr>
+              <a:t>Page opens in the</a:t>
+            </a:r>
+            <a:endParaRPr lang="en-US" sz="1150" dirty="0"/>
+          </a:p>
+          <a:p>
+            <a:pPr algn="ctr" indent="0" marL="0">
+              <a:lnSpc>
+                <a:spcPct val="115000"/>
+              </a:lnSpc>
+              <a:buNone/>
+            </a:pPr>
+            <a:r>
+              <a:rPr lang="en-US" sz="1150" dirty="0">
+                <a:solidFill>
+                  <a:srgbClr val="1A2233"/>
+                </a:solidFill>
+                <a:latin typeface="Calibri" pitchFamily="34" charset="0"/>
+                <a:ea typeface="Calibri" pitchFamily="34" charset="-122"/>
+                <a:cs typeface="Calibri" pitchFamily="34" charset="-120"/>
+              </a:rPr>
+              <a:t>default browser (Chrome)</a:t>
+            </a:r>
+            <a:endParaRPr lang="en-US" sz="1150" dirty="0"/>
+          </a:p>
+        </p:txBody>
+      </p:sp>
+      <p:sp>
+        <p:nvSpPr>
+          <p:cNvPr id="21" name="Shape 19"/>
+          <p:cNvSpPr/>
+          <p:nvPr/>
+        </p:nvSpPr>
+        <p:spPr>
+          <a:xfrm>
+            <a:off x="3182112" y="4434840"/>
+            <a:ext cx="1828800" cy="1234440"/>
+          </a:xfrm>
+          <a:prstGeom prst="roundRect">
+            <a:avLst>
+              <a:gd name="adj" fmla="val 5926"/>
+            </a:avLst>
+          </a:prstGeom>
+          <a:solidFill>
+            <a:srgbClr val="FFFFFF"/>
+          </a:solidFill>
+          <a:ln w="12700">
+            <a:solidFill>
+              <a:srgbClr val="D7DEE5"/>
+            </a:solidFill>
+            <a:prstDash val="solid"/>
+          </a:ln>
+        </p:spPr>
+      </p:sp>
+      <p:sp>
+        <p:nvSpPr>
+          <p:cNvPr id="22" name="Text 20"/>
+          <p:cNvSpPr/>
+          <p:nvPr/>
+        </p:nvSpPr>
+        <p:spPr>
+          <a:xfrm>
+            <a:off x="3291840" y="4434840"/>
+            <a:ext cx="1609344" cy="1234440"/>
+          </a:xfrm>
+          <a:prstGeom prst="rect">
+            <a:avLst/>
+          </a:prstGeom>
+          <a:noFill/>
+          <a:ln/>
+        </p:spPr>
+        <p:txBody>
+          <a:bodyPr wrap="square" lIns="0" tIns="0" rIns="0" bIns="0" rtlCol="0" anchor="ctr"/>
+          <a:lstStyle/>
+          <a:p>
+            <a:pPr algn="ctr" indent="0" marL="0">
+              <a:lnSpc>
+                <a:spcPct val="115000"/>
+              </a:lnSpc>
+              <a:buNone/>
+            </a:pPr>
+            <a:r>
+              <a:rPr lang="en-US" sz="1150" dirty="0">
+                <a:solidFill>
+                  <a:srgbClr val="1A2233"/>
+                </a:solidFill>
+                <a:latin typeface="Calibri" pitchFamily="34" charset="0"/>
+                <a:ea typeface="Calibri" pitchFamily="34" charset="-122"/>
+                <a:cs typeface="Calibri" pitchFamily="34" charset="-120"/>
+              </a:rPr>
+              <a:t>Page opens in</a:t>
+            </a:r>
+            <a:endParaRPr lang="en-US" sz="1150" dirty="0"/>
+          </a:p>
+          <a:p>
+            <a:pPr algn="ctr" indent="0" marL="0">
+              <a:lnSpc>
+                <a:spcPct val="115000"/>
+              </a:lnSpc>
+              <a:buNone/>
+            </a:pPr>
+            <a:r>
+              <a:rPr lang="en-US" sz="1150" dirty="0">
+                <a:solidFill>
+                  <a:srgbClr val="1A2233"/>
+                </a:solidFill>
+                <a:latin typeface="Calibri" pitchFamily="34" charset="0"/>
+                <a:ea typeface="Calibri" pitchFamily="34" charset="-122"/>
+                <a:cs typeface="Calibri" pitchFamily="34" charset="-120"/>
+              </a:rPr>
+              <a:t>Safari</a:t>
+            </a:r>
+            <a:endParaRPr lang="en-US" sz="1150" dirty="0"/>
+          </a:p>
+        </p:txBody>
+      </p:sp>
+      <p:sp>
+        <p:nvSpPr>
+          <p:cNvPr id="23" name="Shape 21"/>
+          <p:cNvSpPr/>
+          <p:nvPr/>
+        </p:nvSpPr>
+        <p:spPr>
+          <a:xfrm>
+            <a:off x="4096512" y="3063240"/>
+            <a:ext cx="0" cy="1371600"/>
+          </a:xfrm>
+          <a:prstGeom prst="line">
+            <a:avLst/>
+          </a:prstGeom>
+          <a:noFill/>
+          <a:ln w="19050">
+            <a:solidFill>
+              <a:srgbClr val="8FD6C4"/>
+            </a:solidFill>
+            <a:prstDash val="solid"/>
+          </a:ln>
+        </p:spPr>
+      </p:sp>
+      <p:sp>
+        <p:nvSpPr>
+          <p:cNvPr id="24" name="Shape 22"/>
+          <p:cNvSpPr/>
+          <p:nvPr/>
+        </p:nvSpPr>
+        <p:spPr>
+          <a:xfrm>
+            <a:off x="3616452" y="3602736"/>
+            <a:ext cx="960120" cy="292608"/>
+          </a:xfrm>
+          <a:prstGeom prst="roundRect">
+            <a:avLst>
+              <a:gd name="adj" fmla="val 50000"/>
+            </a:avLst>
+          </a:prstGeom>
+          <a:solidFill>
+            <a:srgbClr val="5EEAD4"/>
+          </a:solidFill>
+          <a:ln/>
+        </p:spPr>
+      </p:sp>
+      <p:sp>
+        <p:nvSpPr>
+          <p:cNvPr id="25" name="Text 23"/>
+          <p:cNvSpPr/>
+          <p:nvPr/>
+        </p:nvSpPr>
+        <p:spPr>
+          <a:xfrm>
+            <a:off x="3616452" y="3602736"/>
+            <a:ext cx="960120" cy="292608"/>
+          </a:xfrm>
+          <a:prstGeom prst="rect">
+            <a:avLst/>
+          </a:prstGeom>
+          <a:noFill/>
+          <a:ln/>
+        </p:spPr>
+        <p:txBody>
+          <a:bodyPr wrap="square" lIns="0" tIns="0" rIns="0" bIns="0" rtlCol="0" anchor="ctr"/>
+          <a:lstStyle/>
+          <a:p>
+            <a:pPr algn="ctr" indent="0" marL="0">
+              <a:buNone/>
+            </a:pPr>
+            <a:r>
+              <a:rPr lang="en-US" sz="1000" b="1" dirty="0">
+                <a:solidFill>
+                  <a:srgbClr val="0B3B44"/>
+                </a:solidFill>
+                <a:latin typeface="Calibri" pitchFamily="34" charset="0"/>
+                <a:ea typeface="Calibri" pitchFamily="34" charset="-122"/>
+                <a:cs typeface="Calibri" pitchFamily="34" charset="-120"/>
+              </a:rPr>
+              <a:t>same</a:t>
+            </a:r>
+            <a:endParaRPr lang="en-US" sz="1000" dirty="0"/>
+          </a:p>
+        </p:txBody>
+      </p:sp>
+      <p:sp>
+        <p:nvSpPr>
+          <p:cNvPr id="26" name="Shape 24"/>
+          <p:cNvSpPr/>
+          <p:nvPr/>
+        </p:nvSpPr>
+        <p:spPr>
+          <a:xfrm>
+            <a:off x="6016752" y="1517904"/>
+            <a:ext cx="329184" cy="329184"/>
+          </a:xfrm>
+          <a:prstGeom prst="ellipse">
+            <a:avLst/>
+          </a:prstGeom>
+          <a:solidFill>
+            <a:srgbClr val="1A2233"/>
+          </a:solidFill>
+          <a:ln/>
+        </p:spPr>
+      </p:sp>
+      <p:sp>
+        <p:nvSpPr>
+          <p:cNvPr id="27" name="Text 25"/>
+          <p:cNvSpPr/>
+          <p:nvPr/>
+        </p:nvSpPr>
+        <p:spPr>
+          <a:xfrm>
+            <a:off x="6016752" y="1517904"/>
+            <a:ext cx="329184" cy="329184"/>
+          </a:xfrm>
+          <a:prstGeom prst="rect">
+            <a:avLst/>
+          </a:prstGeom>
+          <a:noFill/>
+          <a:ln/>
+        </p:spPr>
+        <p:txBody>
+          <a:bodyPr wrap="square" lIns="0" tIns="0" rIns="0" bIns="0" rtlCol="0" anchor="ctr"/>
+          <a:lstStyle/>
+          <a:p>
+            <a:pPr algn="ctr" indent="0" marL="0">
+              <a:buNone/>
+            </a:pPr>
+            <a:r>
+              <a:rPr lang="en-US" sz="1200" b="1" dirty="0">
+                <a:solidFill>
+                  <a:srgbClr val="FFFFFF"/>
+                </a:solidFill>
+                <a:latin typeface="Calibri" pitchFamily="34" charset="0"/>
+                <a:ea typeface="Calibri" pitchFamily="34" charset="-122"/>
+                <a:cs typeface="Calibri" pitchFamily="34" charset="-120"/>
+              </a:rPr>
+              <a:t>3</a:t>
+            </a:r>
+            <a:endParaRPr lang="en-US" sz="1200" dirty="0"/>
+          </a:p>
+        </p:txBody>
+      </p:sp>
+      <p:sp>
+        <p:nvSpPr>
+          <p:cNvPr id="28" name="Shape 26"/>
+          <p:cNvSpPr/>
+          <p:nvPr/>
+        </p:nvSpPr>
+        <p:spPr>
+          <a:xfrm>
+            <a:off x="5266944" y="1828800"/>
+            <a:ext cx="1828800" cy="1234440"/>
+          </a:xfrm>
+          <a:prstGeom prst="roundRect">
+            <a:avLst>
+              <a:gd name="adj" fmla="val 5926"/>
+            </a:avLst>
+          </a:prstGeom>
+          <a:solidFill>
+            <a:srgbClr val="FFFFFF"/>
+          </a:solidFill>
+          <a:ln w="12700">
+            <a:solidFill>
+              <a:srgbClr val="D7DEE5"/>
+            </a:solidFill>
+            <a:prstDash val="solid"/>
+          </a:ln>
+        </p:spPr>
+      </p:sp>
+      <p:sp>
+        <p:nvSpPr>
+          <p:cNvPr id="29" name="Text 27"/>
+          <p:cNvSpPr/>
+          <p:nvPr/>
+        </p:nvSpPr>
+        <p:spPr>
+          <a:xfrm>
+            <a:off x="5376672" y="1828800"/>
+            <a:ext cx="1609344" cy="1234440"/>
+          </a:xfrm>
+          <a:prstGeom prst="rect">
+            <a:avLst/>
+          </a:prstGeom>
+          <a:noFill/>
+          <a:ln/>
+        </p:spPr>
+        <p:txBody>
+          <a:bodyPr wrap="square" lIns="0" tIns="0" rIns="0" bIns="0" rtlCol="0" anchor="ctr"/>
+          <a:lstStyle/>
+          <a:p>
+            <a:pPr algn="ctr" indent="0" marL="0">
+              <a:lnSpc>
+                <a:spcPct val="115000"/>
+              </a:lnSpc>
+              <a:buNone/>
+            </a:pPr>
+            <a:r>
+              <a:rPr lang="en-US" sz="1150" dirty="0">
+                <a:solidFill>
+                  <a:srgbClr val="1A2233"/>
+                </a:solidFill>
+                <a:latin typeface="Calibri" pitchFamily="34" charset="0"/>
+                <a:ea typeface="Calibri" pitchFamily="34" charset="-122"/>
+                <a:cs typeface="Calibri" pitchFamily="34" charset="-120"/>
+              </a:rPr>
+              <a:t>Tap “Continue to pay”</a:t>
+            </a:r>
+            <a:endParaRPr lang="en-US" sz="1150" dirty="0"/>
+          </a:p>
+          <a:p>
+            <a:pPr algn="ctr" indent="0" marL="0">
+              <a:lnSpc>
+                <a:spcPct val="115000"/>
+              </a:lnSpc>
+              <a:buNone/>
+            </a:pPr>
+            <a:r>
+              <a:rPr lang="en-US" sz="1150" dirty="0">
+                <a:solidFill>
+                  <a:srgbClr val="1A2233"/>
+                </a:solidFill>
+                <a:latin typeface="Calibri" pitchFamily="34" charset="0"/>
+                <a:ea typeface="Calibri" pitchFamily="34" charset="-122"/>
+                <a:cs typeface="Calibri" pitchFamily="34" charset="-120"/>
+              </a:rPr>
+              <a:t>→ native app chooser</a:t>
+            </a:r>
+            <a:endParaRPr lang="en-US" sz="1150" dirty="0"/>
+          </a:p>
+        </p:txBody>
+      </p:sp>
+      <p:sp>
+        <p:nvSpPr>
+          <p:cNvPr id="30" name="Shape 28"/>
+          <p:cNvSpPr/>
+          <p:nvPr/>
+        </p:nvSpPr>
+        <p:spPr>
+          <a:xfrm>
+            <a:off x="5266944" y="4434840"/>
+            <a:ext cx="1828800" cy="1234440"/>
+          </a:xfrm>
+          <a:prstGeom prst="roundRect">
+            <a:avLst>
+              <a:gd name="adj" fmla="val 5926"/>
+            </a:avLst>
+          </a:prstGeom>
+          <a:solidFill>
+            <a:srgbClr val="FFFFFF"/>
+          </a:solidFill>
+          <a:ln w="12700">
+            <a:solidFill>
+              <a:srgbClr val="D7DEE5"/>
+            </a:solidFill>
+            <a:prstDash val="solid"/>
+          </a:ln>
+        </p:spPr>
+      </p:sp>
+      <p:sp>
+        <p:nvSpPr>
+          <p:cNvPr id="31" name="Text 29"/>
+          <p:cNvSpPr/>
+          <p:nvPr/>
+        </p:nvSpPr>
+        <p:spPr>
+          <a:xfrm>
+            <a:off x="5376672" y="4434840"/>
+            <a:ext cx="1609344" cy="1234440"/>
+          </a:xfrm>
+          <a:prstGeom prst="rect">
+            <a:avLst/>
+          </a:prstGeom>
+          <a:noFill/>
+          <a:ln/>
+        </p:spPr>
+        <p:txBody>
+          <a:bodyPr wrap="square" lIns="0" tIns="0" rIns="0" bIns="0" rtlCol="0" anchor="ctr"/>
+          <a:lstStyle/>
+          <a:p>
+            <a:pPr algn="ctr" indent="0" marL="0">
+              <a:lnSpc>
+                <a:spcPct val="115000"/>
+              </a:lnSpc>
+              <a:buNone/>
+            </a:pPr>
+            <a:r>
+              <a:rPr lang="en-US" sz="1150" dirty="0">
+                <a:solidFill>
+                  <a:srgbClr val="1A2233"/>
+                </a:solidFill>
+                <a:latin typeface="Calibri" pitchFamily="34" charset="0"/>
+                <a:ea typeface="Calibri" pitchFamily="34" charset="-122"/>
+                <a:cs typeface="Calibri" pitchFamily="34" charset="-120"/>
+              </a:rPr>
+              <a:t>Tap a bank button</a:t>
+            </a:r>
+            <a:endParaRPr lang="en-US" sz="1150" dirty="0"/>
+          </a:p>
+          <a:p>
+            <a:pPr algn="ctr" indent="0" marL="0">
+              <a:lnSpc>
+                <a:spcPct val="115000"/>
+              </a:lnSpc>
+              <a:buNone/>
+            </a:pPr>
+            <a:r>
+              <a:rPr lang="en-US" sz="1150" dirty="0">
+                <a:solidFill>
+                  <a:srgbClr val="1A2233"/>
+                </a:solidFill>
+                <a:latin typeface="Calibri" pitchFamily="34" charset="0"/>
+                <a:ea typeface="Calibri" pitchFamily="34" charset="-122"/>
+                <a:cs typeface="Calibri" pitchFamily="34" charset="-120"/>
+              </a:rPr>
+              <a:t>on the picker page</a:t>
+            </a:r>
+            <a:endParaRPr lang="en-US" sz="1150" dirty="0"/>
+          </a:p>
+        </p:txBody>
+      </p:sp>
+      <p:sp>
+        <p:nvSpPr>
+          <p:cNvPr id="32" name="Shape 30"/>
+          <p:cNvSpPr/>
+          <p:nvPr/>
+        </p:nvSpPr>
+        <p:spPr>
+          <a:xfrm>
+            <a:off x="6181344" y="3063240"/>
+            <a:ext cx="0" cy="1371600"/>
+          </a:xfrm>
+          <a:prstGeom prst="line">
+            <a:avLst/>
+          </a:prstGeom>
+          <a:noFill/>
+          <a:ln w="19050">
+            <a:solidFill>
+              <a:srgbClr val="F96167"/>
+            </a:solidFill>
+            <a:prstDash val="dash"/>
+          </a:ln>
+        </p:spPr>
+      </p:sp>
+      <p:sp>
+        <p:nvSpPr>
+          <p:cNvPr id="33" name="Shape 31"/>
+          <p:cNvSpPr/>
+          <p:nvPr/>
+        </p:nvSpPr>
+        <p:spPr>
+          <a:xfrm>
+            <a:off x="5701284" y="3602736"/>
+            <a:ext cx="960120" cy="292608"/>
+          </a:xfrm>
+          <a:prstGeom prst="roundRect">
+            <a:avLst>
+              <a:gd name="adj" fmla="val 50000"/>
+            </a:avLst>
+          </a:prstGeom>
+          <a:solidFill>
+            <a:srgbClr val="F96167"/>
+          </a:solidFill>
+          <a:ln/>
+        </p:spPr>
+      </p:sp>
+      <p:sp>
+        <p:nvSpPr>
+          <p:cNvPr id="34" name="Text 32"/>
+          <p:cNvSpPr/>
+          <p:nvPr/>
+        </p:nvSpPr>
+        <p:spPr>
+          <a:xfrm>
+            <a:off x="5701284" y="3602736"/>
+            <a:ext cx="960120" cy="292608"/>
+          </a:xfrm>
+          <a:prstGeom prst="rect">
+            <a:avLst/>
+          </a:prstGeom>
+          <a:noFill/>
+          <a:ln/>
+        </p:spPr>
+        <p:txBody>
+          <a:bodyPr wrap="square" lIns="0" tIns="0" rIns="0" bIns="0" rtlCol="0" anchor="ctr"/>
+          <a:lstStyle/>
+          <a:p>
+            <a:pPr algn="ctr" indent="0" marL="0">
+              <a:buNone/>
+            </a:pPr>
+            <a:r>
+              <a:rPr lang="en-US" sz="1000" b="1" dirty="0">
+                <a:solidFill>
+                  <a:srgbClr val="FFFFFF"/>
+                </a:solidFill>
+                <a:latin typeface="Calibri" pitchFamily="34" charset="0"/>
+                <a:ea typeface="Calibri" pitchFamily="34" charset="-122"/>
+                <a:cs typeface="Calibri" pitchFamily="34" charset="-120"/>
+              </a:rPr>
+              <a:t>differs</a:t>
+            </a:r>
+            <a:endParaRPr lang="en-US" sz="1000" dirty="0"/>
+          </a:p>
+        </p:txBody>
+      </p:sp>
+      <p:sp>
+        <p:nvSpPr>
+          <p:cNvPr id="35" name="Shape 33"/>
+          <p:cNvSpPr/>
+          <p:nvPr/>
+        </p:nvSpPr>
+        <p:spPr>
+          <a:xfrm>
+            <a:off x="8101584" y="1517904"/>
+            <a:ext cx="329184" cy="329184"/>
+          </a:xfrm>
+          <a:prstGeom prst="ellipse">
+            <a:avLst/>
+          </a:prstGeom>
+          <a:solidFill>
+            <a:srgbClr val="1A2233"/>
+          </a:solidFill>
+          <a:ln/>
+        </p:spPr>
+      </p:sp>
+      <p:sp>
+        <p:nvSpPr>
+          <p:cNvPr id="36" name="Text 34"/>
+          <p:cNvSpPr/>
+          <p:nvPr/>
+        </p:nvSpPr>
+        <p:spPr>
+          <a:xfrm>
+            <a:off x="8101584" y="1517904"/>
+            <a:ext cx="329184" cy="329184"/>
+          </a:xfrm>
+          <a:prstGeom prst="rect">
+            <a:avLst/>
+          </a:prstGeom>
+          <a:noFill/>
+          <a:ln/>
+        </p:spPr>
+        <p:txBody>
+          <a:bodyPr wrap="square" lIns="0" tIns="0" rIns="0" bIns="0" rtlCol="0" anchor="ctr"/>
+          <a:lstStyle/>
+          <a:p>
+            <a:pPr algn="ctr" indent="0" marL="0">
+              <a:buNone/>
+            </a:pPr>
+            <a:r>
+              <a:rPr lang="en-US" sz="1200" b="1" dirty="0">
+                <a:solidFill>
+                  <a:srgbClr val="FFFFFF"/>
+                </a:solidFill>
+                <a:latin typeface="Calibri" pitchFamily="34" charset="0"/>
+                <a:ea typeface="Calibri" pitchFamily="34" charset="-122"/>
+                <a:cs typeface="Calibri" pitchFamily="34" charset="-120"/>
+              </a:rPr>
+              <a:t>4</a:t>
+            </a:r>
+            <a:endParaRPr lang="en-US" sz="1200" dirty="0"/>
+          </a:p>
+        </p:txBody>
+      </p:sp>
+      <p:sp>
+        <p:nvSpPr>
+          <p:cNvPr id="37" name="Shape 35"/>
+          <p:cNvSpPr/>
+          <p:nvPr/>
+        </p:nvSpPr>
+        <p:spPr>
+          <a:xfrm>
+            <a:off x="7351776" y="1828800"/>
+            <a:ext cx="1828800" cy="1234440"/>
+          </a:xfrm>
+          <a:prstGeom prst="roundRect">
+            <a:avLst>
+              <a:gd name="adj" fmla="val 5926"/>
+            </a:avLst>
+          </a:prstGeom>
+          <a:solidFill>
+            <a:srgbClr val="FFFFFF"/>
+          </a:solidFill>
+          <a:ln w="12700">
+            <a:solidFill>
+              <a:srgbClr val="D7DEE5"/>
+            </a:solidFill>
+            <a:prstDash val="solid"/>
+          </a:ln>
+        </p:spPr>
+      </p:sp>
+      <p:sp>
+        <p:nvSpPr>
+          <p:cNvPr id="38" name="Text 36"/>
+          <p:cNvSpPr/>
+          <p:nvPr/>
+        </p:nvSpPr>
+        <p:spPr>
+          <a:xfrm>
+            <a:off x="7461504" y="1828800"/>
+            <a:ext cx="1609344" cy="1234440"/>
+          </a:xfrm>
+          <a:prstGeom prst="rect">
+            <a:avLst/>
+          </a:prstGeom>
+          <a:noFill/>
+          <a:ln/>
+        </p:spPr>
+        <p:txBody>
+          <a:bodyPr wrap="square" lIns="0" tIns="0" rIns="0" bIns="0" rtlCol="0" anchor="ctr"/>
+          <a:lstStyle/>
+          <a:p>
+            <a:pPr algn="ctr" indent="0" marL="0">
+              <a:lnSpc>
+                <a:spcPct val="115000"/>
+              </a:lnSpc>
+              <a:buNone/>
+            </a:pPr>
+            <a:r>
+              <a:rPr lang="en-US" sz="1150" dirty="0">
+                <a:solidFill>
+                  <a:srgbClr val="1A2233"/>
+                </a:solidFill>
+                <a:latin typeface="Calibri" pitchFamily="34" charset="0"/>
+                <a:ea typeface="Calibri" pitchFamily="34" charset="-122"/>
+                <a:cs typeface="Calibri" pitchFamily="34" charset="-120"/>
+              </a:rPr>
+              <a:t>Chosen bank app opens</a:t>
+            </a:r>
+            <a:endParaRPr lang="en-US" sz="1150" dirty="0"/>
+          </a:p>
+          <a:p>
+            <a:pPr algn="ctr" indent="0" marL="0">
+              <a:lnSpc>
+                <a:spcPct val="115000"/>
+              </a:lnSpc>
+              <a:buNone/>
+            </a:pPr>
+            <a:r>
+              <a:rPr lang="en-US" sz="1150" dirty="0">
+                <a:solidFill>
+                  <a:srgbClr val="1A2233"/>
+                </a:solidFill>
+                <a:latin typeface="Calibri" pitchFamily="34" charset="0"/>
+                <a:ea typeface="Calibri" pitchFamily="34" charset="-122"/>
+                <a:cs typeface="Calibri" pitchFamily="34" charset="-120"/>
+              </a:rPr>
+              <a:t>to the Confirm screen</a:t>
+            </a:r>
+            <a:endParaRPr lang="en-US" sz="1150" dirty="0"/>
+          </a:p>
+        </p:txBody>
+      </p:sp>
+      <p:sp>
+        <p:nvSpPr>
+          <p:cNvPr id="39" name="Shape 37"/>
+          <p:cNvSpPr/>
+          <p:nvPr/>
+        </p:nvSpPr>
+        <p:spPr>
+          <a:xfrm>
+            <a:off x="7351776" y="4434840"/>
+            <a:ext cx="1828800" cy="1234440"/>
+          </a:xfrm>
+          <a:prstGeom prst="roundRect">
+            <a:avLst>
+              <a:gd name="adj" fmla="val 5926"/>
+            </a:avLst>
+          </a:prstGeom>
+          <a:solidFill>
+            <a:srgbClr val="FFFFFF"/>
+          </a:solidFill>
+          <a:ln w="12700">
+            <a:solidFill>
+              <a:srgbClr val="D7DEE5"/>
+            </a:solidFill>
+            <a:prstDash val="solid"/>
+          </a:ln>
+        </p:spPr>
+      </p:sp>
+      <p:sp>
+        <p:nvSpPr>
+          <p:cNvPr id="40" name="Text 38"/>
+          <p:cNvSpPr/>
+          <p:nvPr/>
+        </p:nvSpPr>
+        <p:spPr>
+          <a:xfrm>
+            <a:off x="7461504" y="4434840"/>
+            <a:ext cx="1609344" cy="1234440"/>
+          </a:xfrm>
+          <a:prstGeom prst="rect">
+            <a:avLst/>
+          </a:prstGeom>
+          <a:noFill/>
+          <a:ln/>
+        </p:spPr>
+        <p:txBody>
+          <a:bodyPr wrap="square" lIns="0" tIns="0" rIns="0" bIns="0" rtlCol="0" anchor="ctr"/>
+          <a:lstStyle/>
+          <a:p>
+            <a:pPr algn="ctr" indent="0" marL="0">
+              <a:lnSpc>
+                <a:spcPct val="115000"/>
+              </a:lnSpc>
+              <a:buNone/>
+            </a:pPr>
+            <a:r>
+              <a:rPr lang="en-US" sz="1150" dirty="0">
+                <a:solidFill>
+                  <a:srgbClr val="1A2233"/>
+                </a:solidFill>
+                <a:latin typeface="Calibri" pitchFamily="34" charset="0"/>
+                <a:ea typeface="Calibri" pitchFamily="34" charset="-122"/>
+                <a:cs typeface="Calibri" pitchFamily="34" charset="-120"/>
+              </a:rPr>
+              <a:t>Chosen bank app opens</a:t>
+            </a:r>
+            <a:endParaRPr lang="en-US" sz="1150" dirty="0"/>
+          </a:p>
+          <a:p>
+            <a:pPr algn="ctr" indent="0" marL="0">
+              <a:lnSpc>
+                <a:spcPct val="115000"/>
+              </a:lnSpc>
+              <a:buNone/>
+            </a:pPr>
+            <a:r>
+              <a:rPr lang="en-US" sz="1150" dirty="0">
+                <a:solidFill>
+                  <a:srgbClr val="1A2233"/>
+                </a:solidFill>
+                <a:latin typeface="Calibri" pitchFamily="34" charset="0"/>
+                <a:ea typeface="Calibri" pitchFamily="34" charset="-122"/>
+                <a:cs typeface="Calibri" pitchFamily="34" charset="-120"/>
+              </a:rPr>
+              <a:t>to the Confirm screen</a:t>
+            </a:r>
+            <a:endParaRPr lang="en-US" sz="1150" dirty="0"/>
+          </a:p>
+        </p:txBody>
+      </p:sp>
+      <p:sp>
+        <p:nvSpPr>
+          <p:cNvPr id="41" name="Shape 39"/>
+          <p:cNvSpPr/>
+          <p:nvPr/>
+        </p:nvSpPr>
+        <p:spPr>
+          <a:xfrm>
+            <a:off x="8266176" y="3063240"/>
+            <a:ext cx="0" cy="1371600"/>
+          </a:xfrm>
+          <a:prstGeom prst="line">
+            <a:avLst/>
+          </a:prstGeom>
+          <a:noFill/>
+          <a:ln w="19050">
+            <a:solidFill>
+              <a:srgbClr val="8FD6C4"/>
+            </a:solidFill>
+            <a:prstDash val="solid"/>
+          </a:ln>
+        </p:spPr>
+      </p:sp>
+      <p:sp>
+        <p:nvSpPr>
+          <p:cNvPr id="42" name="Shape 40"/>
+          <p:cNvSpPr/>
+          <p:nvPr/>
+        </p:nvSpPr>
+        <p:spPr>
+          <a:xfrm>
+            <a:off x="7786116" y="3602736"/>
+            <a:ext cx="960120" cy="292608"/>
+          </a:xfrm>
+          <a:prstGeom prst="roundRect">
+            <a:avLst>
+              <a:gd name="adj" fmla="val 50000"/>
+            </a:avLst>
+          </a:prstGeom>
+          <a:solidFill>
+            <a:srgbClr val="5EEAD4"/>
+          </a:solidFill>
+          <a:ln/>
+        </p:spPr>
+      </p:sp>
+      <p:sp>
+        <p:nvSpPr>
+          <p:cNvPr id="43" name="Text 41"/>
+          <p:cNvSpPr/>
+          <p:nvPr/>
+        </p:nvSpPr>
+        <p:spPr>
+          <a:xfrm>
+            <a:off x="7786116" y="3602736"/>
+            <a:ext cx="960120" cy="292608"/>
+          </a:xfrm>
+          <a:prstGeom prst="rect">
+            <a:avLst/>
+          </a:prstGeom>
+          <a:noFill/>
+          <a:ln/>
+        </p:spPr>
+        <p:txBody>
+          <a:bodyPr wrap="square" lIns="0" tIns="0" rIns="0" bIns="0" rtlCol="0" anchor="ctr"/>
+          <a:lstStyle/>
+          <a:p>
+            <a:pPr algn="ctr" indent="0" marL="0">
+              <a:buNone/>
+            </a:pPr>
+            <a:r>
+              <a:rPr lang="en-US" sz="1000" b="1" dirty="0">
+                <a:solidFill>
+                  <a:srgbClr val="0B3B44"/>
+                </a:solidFill>
+                <a:latin typeface="Calibri" pitchFamily="34" charset="0"/>
+                <a:ea typeface="Calibri" pitchFamily="34" charset="-122"/>
+                <a:cs typeface="Calibri" pitchFamily="34" charset="-120"/>
+              </a:rPr>
+              <a:t>same</a:t>
+            </a:r>
+            <a:endParaRPr lang="en-US" sz="1000" dirty="0"/>
+          </a:p>
+        </p:txBody>
+      </p:sp>
+      <p:sp>
+        <p:nvSpPr>
+          <p:cNvPr id="44" name="Shape 42"/>
+          <p:cNvSpPr/>
+          <p:nvPr/>
+        </p:nvSpPr>
+        <p:spPr>
+          <a:xfrm>
+            <a:off x="10186416" y="1517904"/>
+            <a:ext cx="329184" cy="329184"/>
+          </a:xfrm>
+          <a:prstGeom prst="ellipse">
+            <a:avLst/>
+          </a:prstGeom>
+          <a:solidFill>
+            <a:srgbClr val="1A2233"/>
+          </a:solidFill>
+          <a:ln/>
+        </p:spPr>
+      </p:sp>
+      <p:sp>
+        <p:nvSpPr>
+          <p:cNvPr id="45" name="Text 43"/>
+          <p:cNvSpPr/>
+          <p:nvPr/>
+        </p:nvSpPr>
+        <p:spPr>
+          <a:xfrm>
+            <a:off x="10186416" y="1517904"/>
+            <a:ext cx="329184" cy="329184"/>
+          </a:xfrm>
+          <a:prstGeom prst="rect">
+            <a:avLst/>
+          </a:prstGeom>
+          <a:noFill/>
+          <a:ln/>
+        </p:spPr>
+        <p:txBody>
+          <a:bodyPr wrap="square" lIns="0" tIns="0" rIns="0" bIns="0" rtlCol="0" anchor="ctr"/>
+          <a:lstStyle/>
+          <a:p>
+            <a:pPr algn="ctr" indent="0" marL="0">
+              <a:buNone/>
+            </a:pPr>
+            <a:r>
+              <a:rPr lang="en-US" sz="1200" b="1" dirty="0">
+                <a:solidFill>
+                  <a:srgbClr val="FFFFFF"/>
+                </a:solidFill>
+                <a:latin typeface="Calibri" pitchFamily="34" charset="0"/>
+                <a:ea typeface="Calibri" pitchFamily="34" charset="-122"/>
+                <a:cs typeface="Calibri" pitchFamily="34" charset="-120"/>
+              </a:rPr>
+              <a:t>5</a:t>
+            </a:r>
+            <a:endParaRPr lang="en-US" sz="1200" dirty="0"/>
+          </a:p>
+        </p:txBody>
+      </p:sp>
+      <p:sp>
+        <p:nvSpPr>
+          <p:cNvPr id="46" name="Shape 44"/>
+          <p:cNvSpPr/>
+          <p:nvPr/>
+        </p:nvSpPr>
+        <p:spPr>
+          <a:xfrm>
+            <a:off x="9436608" y="1828800"/>
+            <a:ext cx="1828800" cy="1234440"/>
+          </a:xfrm>
+          <a:prstGeom prst="roundRect">
+            <a:avLst>
+              <a:gd name="adj" fmla="val 5926"/>
+            </a:avLst>
+          </a:prstGeom>
+          <a:solidFill>
+            <a:srgbClr val="FFFFFF"/>
+          </a:solidFill>
+          <a:ln w="12700">
+            <a:solidFill>
+              <a:srgbClr val="D7DEE5"/>
+            </a:solidFill>
+            <a:prstDash val="solid"/>
+          </a:ln>
+        </p:spPr>
+      </p:sp>
+      <p:sp>
+        <p:nvSpPr>
+          <p:cNvPr id="47" name="Text 45"/>
+          <p:cNvSpPr/>
+          <p:nvPr/>
+        </p:nvSpPr>
+        <p:spPr>
+          <a:xfrm>
+            <a:off x="9546336" y="1828800"/>
+            <a:ext cx="1609344" cy="1234440"/>
+          </a:xfrm>
+          <a:prstGeom prst="rect">
+            <a:avLst/>
+          </a:prstGeom>
+          <a:noFill/>
+          <a:ln/>
+        </p:spPr>
+        <p:txBody>
+          <a:bodyPr wrap="square" lIns="0" tIns="0" rIns="0" bIns="0" rtlCol="0" anchor="ctr"/>
+          <a:lstStyle/>
+          <a:p>
+            <a:pPr algn="ctr" indent="0" marL="0">
+              <a:lnSpc>
+                <a:spcPct val="115000"/>
+              </a:lnSpc>
+              <a:buNone/>
+            </a:pPr>
+            <a:r>
+              <a:rPr lang="en-US" sz="1150" dirty="0">
+                <a:solidFill>
+                  <a:srgbClr val="1A2233"/>
+                </a:solidFill>
+                <a:latin typeface="Calibri" pitchFamily="34" charset="0"/>
+                <a:ea typeface="Calibri" pitchFamily="34" charset="-122"/>
+                <a:cs typeface="Calibri" pitchFamily="34" charset="-120"/>
+              </a:rPr>
+              <a:t>Tap Approve —</a:t>
+            </a:r>
+            <a:endParaRPr lang="en-US" sz="1150" dirty="0"/>
+          </a:p>
+          <a:p>
+            <a:pPr algn="ctr" indent="0" marL="0">
+              <a:lnSpc>
+                <a:spcPct val="115000"/>
+              </a:lnSpc>
+              <a:buNone/>
+            </a:pPr>
+            <a:r>
+              <a:rPr lang="en-US" sz="1150" dirty="0">
+                <a:solidFill>
+                  <a:srgbClr val="1A2233"/>
+                </a:solidFill>
+                <a:latin typeface="Calibri" pitchFamily="34" charset="0"/>
+                <a:ea typeface="Calibri" pitchFamily="34" charset="-122"/>
+                <a:cs typeface="Calibri" pitchFamily="34" charset="-120"/>
+              </a:rPr>
+              <a:t>payment goes through</a:t>
+            </a:r>
+            <a:endParaRPr lang="en-US" sz="1150" dirty="0"/>
+          </a:p>
+        </p:txBody>
+      </p:sp>
+      <p:sp>
+        <p:nvSpPr>
+          <p:cNvPr id="48" name="Shape 46"/>
+          <p:cNvSpPr/>
+          <p:nvPr/>
+        </p:nvSpPr>
+        <p:spPr>
+          <a:xfrm>
+            <a:off x="9436608" y="4434840"/>
+            <a:ext cx="1828800" cy="1234440"/>
+          </a:xfrm>
+          <a:prstGeom prst="roundRect">
+            <a:avLst>
+              <a:gd name="adj" fmla="val 5926"/>
+            </a:avLst>
+          </a:prstGeom>
+          <a:solidFill>
+            <a:srgbClr val="FFFFFF"/>
+          </a:solidFill>
+          <a:ln w="12700">
+            <a:solidFill>
+              <a:srgbClr val="D7DEE5"/>
+            </a:solidFill>
+            <a:prstDash val="solid"/>
+          </a:ln>
+        </p:spPr>
+      </p:sp>
+      <p:sp>
+        <p:nvSpPr>
+          <p:cNvPr id="49" name="Text 47"/>
+          <p:cNvSpPr/>
+          <p:nvPr/>
+        </p:nvSpPr>
+        <p:spPr>
+          <a:xfrm>
+            <a:off x="9546336" y="4434840"/>
+            <a:ext cx="1609344" cy="1234440"/>
+          </a:xfrm>
+          <a:prstGeom prst="rect">
+            <a:avLst/>
+          </a:prstGeom>
+          <a:noFill/>
+          <a:ln/>
+        </p:spPr>
+        <p:txBody>
+          <a:bodyPr wrap="square" lIns="0" tIns="0" rIns="0" bIns="0" rtlCol="0" anchor="ctr"/>
+          <a:lstStyle/>
+          <a:p>
+            <a:pPr algn="ctr" indent="0" marL="0">
+              <a:lnSpc>
+                <a:spcPct val="115000"/>
+              </a:lnSpc>
+              <a:buNone/>
+            </a:pPr>
+            <a:r>
+              <a:rPr lang="en-US" sz="1150" dirty="0">
+                <a:solidFill>
+                  <a:srgbClr val="1A2233"/>
+                </a:solidFill>
+                <a:latin typeface="Calibri" pitchFamily="34" charset="0"/>
+                <a:ea typeface="Calibri" pitchFamily="34" charset="-122"/>
+                <a:cs typeface="Calibri" pitchFamily="34" charset="-120"/>
+              </a:rPr>
+              <a:t>Tap Approve —</a:t>
+            </a:r>
+            <a:endParaRPr lang="en-US" sz="1150" dirty="0"/>
+          </a:p>
+          <a:p>
+            <a:pPr algn="ctr" indent="0" marL="0">
+              <a:lnSpc>
+                <a:spcPct val="115000"/>
+              </a:lnSpc>
+              <a:buNone/>
+            </a:pPr>
+            <a:r>
+              <a:rPr lang="en-US" sz="1150" dirty="0">
+                <a:solidFill>
+                  <a:srgbClr val="1A2233"/>
+                </a:solidFill>
+                <a:latin typeface="Calibri" pitchFamily="34" charset="0"/>
+                <a:ea typeface="Calibri" pitchFamily="34" charset="-122"/>
+                <a:cs typeface="Calibri" pitchFamily="34" charset="-120"/>
+              </a:rPr>
+              <a:t>payment goes through</a:t>
+            </a:r>
+            <a:endParaRPr lang="en-US" sz="1150" dirty="0"/>
+          </a:p>
+        </p:txBody>
+      </p:sp>
+      <p:sp>
+        <p:nvSpPr>
+          <p:cNvPr id="50" name="Shape 48"/>
+          <p:cNvSpPr/>
+          <p:nvPr/>
+        </p:nvSpPr>
+        <p:spPr>
+          <a:xfrm>
+            <a:off x="10351008" y="3063240"/>
+            <a:ext cx="0" cy="1371600"/>
+          </a:xfrm>
+          <a:prstGeom prst="line">
+            <a:avLst/>
+          </a:prstGeom>
+          <a:noFill/>
+          <a:ln w="19050">
+            <a:solidFill>
+              <a:srgbClr val="8FD6C4"/>
+            </a:solidFill>
+            <a:prstDash val="solid"/>
+          </a:ln>
+        </p:spPr>
+      </p:sp>
+      <p:sp>
+        <p:nvSpPr>
+          <p:cNvPr id="51" name="Shape 49"/>
+          <p:cNvSpPr/>
+          <p:nvPr/>
+        </p:nvSpPr>
+        <p:spPr>
+          <a:xfrm>
+            <a:off x="9870948" y="3602736"/>
+            <a:ext cx="960120" cy="292608"/>
+          </a:xfrm>
+          <a:prstGeom prst="roundRect">
+            <a:avLst>
+              <a:gd name="adj" fmla="val 50000"/>
+            </a:avLst>
+          </a:prstGeom>
+          <a:solidFill>
+            <a:srgbClr val="5EEAD4"/>
+          </a:solidFill>
+          <a:ln/>
+        </p:spPr>
+      </p:sp>
+      <p:sp>
+        <p:nvSpPr>
+          <p:cNvPr id="52" name="Text 50"/>
+          <p:cNvSpPr/>
+          <p:nvPr/>
+        </p:nvSpPr>
+        <p:spPr>
+          <a:xfrm>
+            <a:off x="9870948" y="3602736"/>
+            <a:ext cx="960120" cy="292608"/>
+          </a:xfrm>
+          <a:prstGeom prst="rect">
+            <a:avLst/>
+          </a:prstGeom>
+          <a:noFill/>
+          <a:ln/>
+        </p:spPr>
+        <p:txBody>
+          <a:bodyPr wrap="square" lIns="0" tIns="0" rIns="0" bIns="0" rtlCol="0" anchor="ctr"/>
+          <a:lstStyle/>
+          <a:p>
+            <a:pPr algn="ctr" indent="0" marL="0">
+              <a:buNone/>
+            </a:pPr>
+            <a:r>
+              <a:rPr lang="en-US" sz="1000" b="1" dirty="0">
+                <a:solidFill>
+                  <a:srgbClr val="0B3B44"/>
+                </a:solidFill>
+                <a:latin typeface="Calibri" pitchFamily="34" charset="0"/>
+                <a:ea typeface="Calibri" pitchFamily="34" charset="-122"/>
+                <a:cs typeface="Calibri" pitchFamily="34" charset="-120"/>
+              </a:rPr>
+              <a:t>same</a:t>
+            </a:r>
+            <a:endParaRPr lang="en-US" sz="1000" dirty="0"/>
+          </a:p>
+        </p:txBody>
+      </p:sp>
+      <p:sp>
+        <p:nvSpPr>
+          <p:cNvPr id="53" name="Shape 51"/>
+          <p:cNvSpPr/>
+          <p:nvPr/>
+        </p:nvSpPr>
+        <p:spPr>
+          <a:xfrm>
+            <a:off x="548640" y="5989320"/>
+            <a:ext cx="11091672" cy="685800"/>
+          </a:xfrm>
+          <a:prstGeom prst="roundRect">
+            <a:avLst>
+              <a:gd name="adj" fmla="val 10667"/>
+            </a:avLst>
+          </a:prstGeom>
+          <a:solidFill>
+            <a:srgbClr val="21295C"/>
+          </a:solidFill>
+          <a:ln/>
+        </p:spPr>
+      </p:sp>
+      <p:sp>
+        <p:nvSpPr>
+          <p:cNvPr id="54" name="Text 52"/>
+          <p:cNvSpPr/>
+          <p:nvPr/>
+        </p:nvSpPr>
+        <p:spPr>
+          <a:xfrm>
+            <a:off x="822960" y="5989320"/>
+            <a:ext cx="10515600" cy="685800"/>
+          </a:xfrm>
+          <a:prstGeom prst="rect">
+            <a:avLst/>
+          </a:prstGeom>
+          <a:noFill/>
+          <a:ln/>
+        </p:spPr>
+        <p:txBody>
+          <a:bodyPr wrap="square" lIns="0" tIns="0" rIns="0" bIns="0" rtlCol="0" anchor="ctr"/>
+          <a:lstStyle/>
+          <a:p>
+            <a:pPr indent="0" marL="0">
+              <a:lnSpc>
+                <a:spcPct val="120000"/>
+              </a:lnSpc>
+              <a:buNone/>
+            </a:pPr>
+            <a:r>
+              <a:rPr lang="en-US" sz="1250" dirty="0">
+                <a:solidFill>
+                  <a:srgbClr val="E4ECF5"/>
+                </a:solidFill>
+                <a:latin typeface="Calibri" pitchFamily="34" charset="0"/>
+                <a:ea typeface="Calibri" pitchFamily="34" charset="-122"/>
+                <a:cs typeface="Calibri" pitchFamily="34" charset="-120"/>
+              </a:rPr>
+              <a:t>From the user's side, it's one QR code and the same 5 beats every time — the only thing that changes is the mechanic behind step 3, driven entirely by how each OS treats an unregistered link.</a:t>
+            </a:r>
+            <a:endParaRPr lang="en-US" sz="1250" dirty="0"/>
+          </a:p>
+        </p:txBody>
+      </p:sp>
+    </p:spTree>
+  </p:cSld>
+  <p:clrMapOvr>
+    <a:masterClrMapping/>
+  </p:clrMapOvr>
+</p:sld>
+</file>
+
 <file path=ppt/theme/theme1.xml><?xml version="1.0" encoding="utf-8"?>
 <a:theme xmlns:a="http://schemas.openxmlformats.org/drawingml/2006/main" name="Office Theme">
   <a:themeElements>

</xml_diff>

<commit_message>
Add 2 sequence diagrams for the new methods to the sequence-diagram deck
- Bank 1 (Verified App Links): shows the browser hop disappearing
  entirely once domain ownership is proven at install time.
- Cross-platform check: shows Bank 2 (iOS-only) installed on Android
  falling straight through to Chrome, confirming it's never even
  considered a candidate — the live-tested negative case.

Co-Authored-By: Claude Sonnet 5 <noreply@anthropic.com>
</commit_message>
<xml_diff>
--- a/SGQR_Sequence_Diagrams.pptx
+++ b/SGQR_Sequence_Diagrams.pptx
@@ -9,6 +9,8 @@
     <p:sldId id="257" r:id="rId3"/>
     <p:sldId id="258" r:id="rId4"/>
     <p:sldId id="259" r:id="rId5"/>
+    <p:sldId id="261" r:id="rId12"/>
+    <p:sldId id="260" r:id="rId11"/>
   </p:sldIdLst>
   <p:notesMasterIdLst>
     <p:notesMasterId r:id="rId6"/>
@@ -6850,6 +6852,118 @@
 </p:sld>
 </file>
 
+<file path=ppt/slides/slide5.xml><?xml version="1.0" encoding="utf-8"?>
+<p:sld xmlns:a="http://schemas.openxmlformats.org/drawingml/2006/main" xmlns:r="http://schemas.openxmlformats.org/officeDocument/2006/relationships" xmlns:p="http://schemas.openxmlformats.org/presentationml/2006/main">
+  <p:cSld name="Slide 5">
+    <p:bg>
+      <p:bgPr>
+        <a:solidFill>
+          <a:srgbClr val="FFFFFF"/>
+        </a:solidFill>
+      </p:bgPr>
+    </p:bg>
+    <p:spTree>
+      <p:nvGrpSpPr>
+        <p:cNvPr id="1" name=""/>
+        <p:cNvGrpSpPr/>
+        <p:nvPr/>
+      </p:nvGrpSpPr>
+      <p:grpSpPr>
+        <a:xfrm>
+          <a:off x="0" y="0"/>
+          <a:ext cx="0" cy="0"/>
+          <a:chOff x="0" y="0"/>
+          <a:chExt cx="0" cy="0"/>
+        </a:xfrm>
+      </p:grpSpPr>
+      <p:pic>
+        <p:nvPicPr>
+          <p:cNvPr id="2" name="Diagram"/>
+          <p:cNvPicPr>
+            <a:picLocks noChangeAspect="1"/>
+          </p:cNvPicPr>
+          <p:nvPr/>
+        </p:nvPicPr>
+        <p:blipFill>
+          <a:blip r:embed="rId3"/>
+          <a:stretch>
+            <a:fillRect/>
+          </a:stretch>
+        </p:blipFill>
+        <p:spPr>
+          <a:xfrm>
+            <a:off x="346000" y="112862"/>
+            <a:ext cx="11500000" cy="6632275"/>
+          </a:xfrm>
+          <a:prstGeom prst="rect">
+            <a:avLst/>
+          </a:prstGeom>
+        </p:spPr>
+      </p:pic>
+    </p:spTree>
+  </p:cSld>
+  <p:clrMapOvr>
+    <a:overrideClrMapping bg1="lt1" tx1="dk1" bg2="lt2" tx2="dk2" accent1="accent1" accent2="accent2" accent3="accent3" accent4="accent4" accent5="accent5" accent6="accent6" hlink="hlink" folHlink="folHlink"/>
+  </p:clrMapOvr>
+</p:sld>
+</file>
+
+<file path=ppt/slides/slide6.xml><?xml version="1.0" encoding="utf-8"?>
+<p:sld xmlns:a="http://schemas.openxmlformats.org/drawingml/2006/main" xmlns:r="http://schemas.openxmlformats.org/officeDocument/2006/relationships" xmlns:p="http://schemas.openxmlformats.org/presentationml/2006/main">
+  <p:cSld name="Slide 6">
+    <p:bg>
+      <p:bgPr>
+        <a:solidFill>
+          <a:srgbClr val="FFFFFF"/>
+        </a:solidFill>
+      </p:bgPr>
+    </p:bg>
+    <p:spTree>
+      <p:nvGrpSpPr>
+        <p:cNvPr id="1" name=""/>
+        <p:cNvGrpSpPr/>
+        <p:nvPr/>
+      </p:nvGrpSpPr>
+      <p:grpSpPr>
+        <a:xfrm>
+          <a:off x="0" y="0"/>
+          <a:ext cx="0" cy="0"/>
+          <a:chOff x="0" y="0"/>
+          <a:chExt cx="0" cy="0"/>
+        </a:xfrm>
+      </p:grpSpPr>
+      <p:pic>
+        <p:nvPicPr>
+          <p:cNvPr id="2" name="Diagram"/>
+          <p:cNvPicPr>
+            <a:picLocks noChangeAspect="1"/>
+          </p:cNvPicPr>
+          <p:nvPr/>
+        </p:nvPicPr>
+        <p:blipFill>
+          <a:blip r:embed="rId3"/>
+          <a:stretch>
+            <a:fillRect/>
+          </a:stretch>
+        </p:blipFill>
+        <p:spPr>
+          <a:xfrm>
+            <a:off x="346000" y="112862"/>
+            <a:ext cx="11500000" cy="6632275"/>
+          </a:xfrm>
+          <a:prstGeom prst="rect">
+            <a:avLst/>
+          </a:prstGeom>
+        </p:spPr>
+      </p:pic>
+    </p:spTree>
+  </p:cSld>
+  <p:clrMapOvr>
+    <a:overrideClrMapping bg1="lt1" tx1="dk1" bg2="lt2" tx2="dk2" accent1="accent1" accent2="accent2" accent3="accent3" accent4="accent4" accent5="accent5" accent6="accent6" hlink="hlink" folHlink="folHlink"/>
+  </p:clrMapOvr>
+</p:sld>
+</file>
+
 <file path=ppt/theme/theme1.xml><?xml version="1.0" encoding="utf-8"?>
 <a:theme xmlns:a="http://schemas.openxmlformats.org/drawingml/2006/main" name="Office Theme">
   <a:themeElements>

</xml_diff>

<commit_message>
Add native all-5-banks summary slide to sequence-diagram deck
The 2 sequence diagrams added previously were embedded images, so
"Bank 1"/"Bank 2" text wasn't actually searchable in the deck, and
Bank 3/4/5 didn't appear at all. Adds a native (real text, not image)
table slide covering all 5 apps' mechanism and live-tested result, so
every document now explicitly covers Bank 1 through Bank 5.

Co-Authored-By: Claude Sonnet 5 <noreply@anthropic.com>
</commit_message>
<xml_diff>
--- a/SGQR_Sequence_Diagrams.pptx
+++ b/SGQR_Sequence_Diagrams.pptx
@@ -11,6 +11,7 @@
     <p:sldId id="259" r:id="rId5"/>
     <p:sldId id="261" r:id="rId12"/>
     <p:sldId id="260" r:id="rId11"/>
+    <p:sldId id="262" r:id="rId13"/>
   </p:sldIdLst>
   <p:notesMasterIdLst>
     <p:notesMasterId r:id="rId6"/>
@@ -6956,6 +6957,1150 @@
           </a:prstGeom>
         </p:spPr>
       </p:pic>
+    </p:spTree>
+  </p:cSld>
+  <p:clrMapOvr>
+    <a:overrideClrMapping bg1="lt1" tx1="dk1" bg2="lt2" tx2="dk2" accent1="accent1" accent2="accent2" accent3="accent3" accent4="accent4" accent5="accent5" accent6="accent6" hlink="hlink" folHlink="folHlink"/>
+  </p:clrMapOvr>
+</p:sld>
+</file>
+
+<file path=ppt/slides/slide7.xml><?xml version="1.0" encoding="utf-8"?>
+<p:sld xmlns:a="http://schemas.openxmlformats.org/drawingml/2006/main" xmlns:r="http://schemas.openxmlformats.org/officeDocument/2006/relationships" xmlns:p="http://schemas.openxmlformats.org/presentationml/2006/main">
+  <p:cSld name="Slide 7">
+    <p:bg>
+      <p:bgPr>
+        <a:solidFill>
+          <a:srgbClr val="FFFFFF"/>
+        </a:solidFill>
+      </p:bgPr>
+    </p:bg>
+    <p:spTree>
+      <p:nvGrpSpPr>
+        <p:cNvPr id="1" name=""/>
+        <p:cNvGrpSpPr/>
+        <p:nvPr/>
+      </p:nvGrpSpPr>
+      <p:grpSpPr>
+        <a:xfrm>
+          <a:off x="0" y="0"/>
+          <a:ext cx="0" cy="0"/>
+          <a:chOff x="0" y="0"/>
+          <a:chExt cx="0" cy="0"/>
+        </a:xfrm>
+      </p:grpSpPr>
+      <p:sp>
+        <p:nvSpPr>
+          <p:cNvPr id="2" name="Title"/>
+          <p:cNvSpPr/>
+          <p:nvPr/>
+        </p:nvSpPr>
+        <p:spPr>
+          <a:xfrm>
+            <a:off x="548640" y="330000"/>
+            <a:ext cx="11094720" cy="548640"/>
+          </a:xfrm>
+          <a:prstGeom prst="rect">
+            <a:avLst/>
+          </a:prstGeom>
+          <a:noFill/>
+          <a:ln/>
+        </p:spPr>
+        <p:txBody>
+          <a:bodyPr wrap="square" lIns="0" tIns="0" rIns="0" bIns="0" rtlCol="0" anchor="ctr"/>
+          <a:lstStyle/>
+          <a:p>
+            <a:pPr indent="0" marL="0">
+              <a:buNone/>
+            </a:pPr>
+            <a:r>
+              <a:rPr lang="en-US" sz="2800" b="1" dirty="0">
+                <a:solidFill>
+                  <a:srgbClr val="21295C"/>
+                </a:solidFill>
+                <a:latin typeface="Cambria" pitchFamily="34" charset="0"/>
+                <a:ea typeface="Cambria" pitchFamily="34" charset="-122"/>
+                <a:cs typeface="Cambria" pitchFamily="34" charset="-120"/>
+              </a:rPr>
+              <a:t>All 5 Methods, Sequence by Sequence</a:t>
+            </a:r>
+          </a:p>
+        </p:txBody>
+      </p:sp>
+      <p:sp>
+        <p:nvSpPr>
+          <p:cNvPr id="3" name="Subtitle"/>
+          <p:cNvSpPr/>
+          <p:nvPr/>
+        </p:nvSpPr>
+        <p:spPr>
+          <a:xfrm>
+            <a:off x="548640" y="980000"/>
+            <a:ext cx="11094720" cy="400000"/>
+          </a:xfrm>
+          <a:prstGeom prst="rect">
+            <a:avLst/>
+          </a:prstGeom>
+          <a:noFill/>
+          <a:ln/>
+        </p:spPr>
+        <p:txBody>
+          <a:bodyPr wrap="square" lIns="0" tIns="0" rIns="0" bIns="0" rtlCol="0" anchor="t"/>
+          <a:lstStyle/>
+          <a:p>
+            <a:pPr indent="0" marL="0">
+              <a:buNone/>
+            </a:pPr>
+            <a:r>
+              <a:rPr lang="en-US" sz="1400" i="1" dirty="0">
+                <a:solidFill>
+                  <a:srgbClr val="5B6B79"/>
+                </a:solidFill>
+                <a:latin typeface="Calibri" pitchFamily="34" charset="0"/>
+                <a:ea typeface="Calibri" pitchFamily="34" charset="-122"/>
+                <a:cs typeface="Calibri" pitchFamily="34" charset="-120"/>
+              </a:rPr>
+              <a:t>Bank 1 through Bank 5 — how each one actually resolves, confirmed live on real devices</a:t>
+            </a:r>
+          </a:p>
+        </p:txBody>
+      </p:sp>
+      <p:sp>
+        <p:nvSpPr>
+          <p:cNvPr id="11" name="THead"/>
+          <p:cNvSpPr/>
+          <p:nvPr/>
+        </p:nvSpPr>
+        <p:spPr>
+          <a:xfrm>
+            <a:off x="548640" y="1750000"/>
+            <a:ext cx="2100000" cy="500000"/>
+          </a:xfrm>
+          <a:prstGeom prst="rect">
+            <a:avLst/>
+          </a:prstGeom>
+          <a:solidFill>
+            <a:srgbClr val="21295C"/>
+          </a:solidFill>
+          <a:ln>
+            <a:noFill/>
+          </a:ln>
+        </p:spPr>
+        <p:txBody>
+          <a:bodyPr wrap="square" lIns="90000" tIns="45000" rIns="90000" bIns="45000" anchor="ctr"/>
+          <a:lstStyle/>
+          <a:p>
+            <a:pPr indent="0" marL="0">
+              <a:buNone/>
+            </a:pPr>
+            <a:r>
+              <a:rPr lang="en-US" sz="1250" b="1" dirty="0">
+                <a:solidFill>
+                  <a:srgbClr val="FFFFFF"/>
+                </a:solidFill>
+                <a:latin typeface="Calibri" pitchFamily="34" charset="0"/>
+              </a:rPr>
+              <a:t>App</a:t>
+            </a:r>
+          </a:p>
+        </p:txBody>
+      </p:sp>
+      <p:sp>
+        <p:nvSpPr>
+          <p:cNvPr id="12" name="THead"/>
+          <p:cNvSpPr/>
+          <p:nvPr/>
+        </p:nvSpPr>
+        <p:spPr>
+          <a:xfrm>
+            <a:off x="2648640" y="1750000"/>
+            <a:ext cx="2900000" cy="500000"/>
+          </a:xfrm>
+          <a:prstGeom prst="rect">
+            <a:avLst/>
+          </a:prstGeom>
+          <a:solidFill>
+            <a:srgbClr val="21295C"/>
+          </a:solidFill>
+          <a:ln>
+            <a:noFill/>
+          </a:ln>
+        </p:spPr>
+        <p:txBody>
+          <a:bodyPr wrap="square" lIns="90000" tIns="45000" rIns="90000" bIns="45000" anchor="ctr"/>
+          <a:lstStyle/>
+          <a:p>
+            <a:pPr indent="0" marL="0">
+              <a:buNone/>
+            </a:pPr>
+            <a:r>
+              <a:rPr lang="en-US" sz="1250" b="1" dirty="0">
+                <a:solidFill>
+                  <a:srgbClr val="FFFFFF"/>
+                </a:solidFill>
+                <a:latin typeface="Calibri" pitchFamily="34" charset="0"/>
+              </a:rPr>
+              <a:t>Mechanism</a:t>
+            </a:r>
+          </a:p>
+        </p:txBody>
+      </p:sp>
+      <p:sp>
+        <p:nvSpPr>
+          <p:cNvPr id="13" name="THead"/>
+          <p:cNvSpPr/>
+          <p:nvPr/>
+        </p:nvSpPr>
+        <p:spPr>
+          <a:xfrm>
+            <a:off x="5548640" y="1750000"/>
+            <a:ext cx="2700000" cy="500000"/>
+          </a:xfrm>
+          <a:prstGeom prst="rect">
+            <a:avLst/>
+          </a:prstGeom>
+          <a:solidFill>
+            <a:srgbClr val="21295C"/>
+          </a:solidFill>
+          <a:ln>
+            <a:noFill/>
+          </a:ln>
+        </p:spPr>
+        <p:txBody>
+          <a:bodyPr wrap="square" lIns="90000" tIns="45000" rIns="90000" bIns="45000" anchor="ctr"/>
+          <a:lstStyle/>
+          <a:p>
+            <a:pPr indent="0" marL="0">
+              <a:buNone/>
+            </a:pPr>
+            <a:r>
+              <a:rPr lang="en-US" sz="1250" b="1" dirty="0">
+                <a:solidFill>
+                  <a:srgbClr val="FFFFFF"/>
+                </a:solidFill>
+                <a:latin typeface="Calibri" pitchFamily="34" charset="0"/>
+              </a:rPr>
+              <a:t>Resolves via</a:t>
+            </a:r>
+          </a:p>
+        </p:txBody>
+      </p:sp>
+      <p:sp>
+        <p:nvSpPr>
+          <p:cNvPr id="14" name="THead"/>
+          <p:cNvSpPr/>
+          <p:nvPr/>
+        </p:nvSpPr>
+        <p:spPr>
+          <a:xfrm>
+            <a:off x="8248640" y="1750000"/>
+            <a:ext cx="3400000" cy="500000"/>
+          </a:xfrm>
+          <a:prstGeom prst="rect">
+            <a:avLst/>
+          </a:prstGeom>
+          <a:solidFill>
+            <a:srgbClr val="21295C"/>
+          </a:solidFill>
+          <a:ln>
+            <a:noFill/>
+          </a:ln>
+        </p:spPr>
+        <p:txBody>
+          <a:bodyPr wrap="square" lIns="90000" tIns="45000" rIns="90000" bIns="45000" anchor="ctr"/>
+          <a:lstStyle/>
+          <a:p>
+            <a:pPr indent="0" marL="0">
+              <a:buNone/>
+            </a:pPr>
+            <a:r>
+              <a:rPr lang="en-US" sz="1250" b="1" dirty="0">
+                <a:solidFill>
+                  <a:srgbClr val="FFFFFF"/>
+                </a:solidFill>
+                <a:latin typeface="Calibri" pitchFamily="34" charset="0"/>
+              </a:rPr>
+              <a:t>Live result</a:t>
+            </a:r>
+          </a:p>
+        </p:txBody>
+      </p:sp>
+      <p:sp>
+        <p:nvSpPr>
+          <p:cNvPr id="15" name="TCell"/>
+          <p:cNvSpPr/>
+          <p:nvPr/>
+        </p:nvSpPr>
+        <p:spPr>
+          <a:xfrm>
+            <a:off x="548640" y="2250000"/>
+            <a:ext cx="2100000" cy="700000"/>
+          </a:xfrm>
+          <a:prstGeom prst="rect">
+            <a:avLst/>
+          </a:prstGeom>
+          <a:solidFill>
+            <a:srgbClr val="FFFFFF"/>
+          </a:solidFill>
+          <a:ln w="6350">
+            <a:solidFill>
+              <a:srgbClr val="D9D9D9"/>
+            </a:solidFill>
+          </a:ln>
+        </p:spPr>
+        <p:txBody>
+          <a:bodyPr wrap="square" lIns="90000" tIns="40000" rIns="90000" bIns="40000" anchor="ctr"/>
+          <a:lstStyle/>
+          <a:p>
+            <a:pPr indent="0" marL="0">
+              <a:buNone/>
+            </a:pPr>
+            <a:r>
+              <a:rPr lang="en-US" sz="1050" b="1" dirty="0">
+                <a:solidFill>
+                  <a:srgbClr val="1A2233"/>
+                </a:solidFill>
+                <a:latin typeface="Calibri" pitchFamily="34" charset="0"/>
+              </a:rPr>
+              <a:t>Bank 1</a:t>
+            </a:r>
+          </a:p>
+        </p:txBody>
+      </p:sp>
+      <p:sp>
+        <p:nvSpPr>
+          <p:cNvPr id="16" name="TCell"/>
+          <p:cNvSpPr/>
+          <p:nvPr/>
+        </p:nvSpPr>
+        <p:spPr>
+          <a:xfrm>
+            <a:off x="2648640" y="2250000"/>
+            <a:ext cx="2900000" cy="700000"/>
+          </a:xfrm>
+          <a:prstGeom prst="rect">
+            <a:avLst/>
+          </a:prstGeom>
+          <a:solidFill>
+            <a:srgbClr val="FFFFFF"/>
+          </a:solidFill>
+          <a:ln w="6350">
+            <a:solidFill>
+              <a:srgbClr val="D9D9D9"/>
+            </a:solidFill>
+          </a:ln>
+        </p:spPr>
+        <p:txBody>
+          <a:bodyPr wrap="square" lIns="90000" tIns="40000" rIns="90000" bIns="40000" anchor="ctr"/>
+          <a:lstStyle/>
+          <a:p>
+            <a:pPr indent="0" marL="0">
+              <a:buNone/>
+            </a:pPr>
+            <a:r>
+              <a:rPr lang="en-US" sz="1050" dirty="0">
+                <a:solidFill>
+                  <a:srgbClr val="1A2233"/>
+                </a:solidFill>
+                <a:latin typeface="Calibri" pitchFamily="34" charset="0"/>
+              </a:rPr>
+              <a:t>Verified Android App Links</a:t>
+            </a:r>
+          </a:p>
+        </p:txBody>
+      </p:sp>
+      <p:sp>
+        <p:nvSpPr>
+          <p:cNvPr id="17" name="TCell"/>
+          <p:cNvSpPr/>
+          <p:nvPr/>
+        </p:nvSpPr>
+        <p:spPr>
+          <a:xfrm>
+            <a:off x="5548640" y="2250000"/>
+            <a:ext cx="2700000" cy="700000"/>
+          </a:xfrm>
+          <a:prstGeom prst="rect">
+            <a:avLst/>
+          </a:prstGeom>
+          <a:solidFill>
+            <a:srgbClr val="FFFFFF"/>
+          </a:solidFill>
+          <a:ln w="6350">
+            <a:solidFill>
+              <a:srgbClr val="D9D9D9"/>
+            </a:solidFill>
+          </a:ln>
+        </p:spPr>
+        <p:txBody>
+          <a:bodyPr wrap="square" lIns="90000" tIns="40000" rIns="90000" bIns="40000" anchor="ctr"/>
+          <a:lstStyle/>
+          <a:p>
+            <a:pPr indent="0" marL="0">
+              <a:buNone/>
+            </a:pPr>
+            <a:r>
+              <a:rPr lang="en-US" sz="1050" dirty="0">
+                <a:solidFill>
+                  <a:srgbClr val="1A2233"/>
+                </a:solidFill>
+                <a:latin typeface="Calibri" pitchFamily="34" charset="0"/>
+              </a:rPr>
+              <a:t>OS-verified ownership → direct launch</a:t>
+            </a:r>
+          </a:p>
+        </p:txBody>
+      </p:sp>
+      <p:sp>
+        <p:nvSpPr>
+          <p:cNvPr id="18" name="TCell"/>
+          <p:cNvSpPr/>
+          <p:nvPr/>
+        </p:nvSpPr>
+        <p:spPr>
+          <a:xfrm>
+            <a:off x="8248640" y="2250000"/>
+            <a:ext cx="3400000" cy="700000"/>
+          </a:xfrm>
+          <a:prstGeom prst="rect">
+            <a:avLst/>
+          </a:prstGeom>
+          <a:solidFill>
+            <a:srgbClr val="E8F5F0"/>
+          </a:solidFill>
+          <a:ln w="6350">
+            <a:solidFill>
+              <a:srgbClr val="D9D9D9"/>
+            </a:solidFill>
+          </a:ln>
+        </p:spPr>
+        <p:txBody>
+          <a:bodyPr wrap="square" lIns="90000" tIns="40000" rIns="90000" bIns="40000" anchor="ctr"/>
+          <a:lstStyle/>
+          <a:p>
+            <a:pPr indent="0" marL="0">
+              <a:buNone/>
+            </a:pPr>
+            <a:r>
+              <a:rPr lang="en-US" sz="1050" dirty="0">
+                <a:solidFill>
+                  <a:srgbClr val="1A2233"/>
+                </a:solidFill>
+                <a:latin typeface="Calibri" pitchFamily="34" charset="0"/>
+              </a:rPr>
+              <a:t>Opens directly, zero prompt</a:t>
+            </a:r>
+          </a:p>
+        </p:txBody>
+      </p:sp>
+      <p:sp>
+        <p:nvSpPr>
+          <p:cNvPr id="19" name="TCell"/>
+          <p:cNvSpPr/>
+          <p:nvPr/>
+        </p:nvSpPr>
+        <p:spPr>
+          <a:xfrm>
+            <a:off x="548640" y="2950000"/>
+            <a:ext cx="2100000" cy="700000"/>
+          </a:xfrm>
+          <a:prstGeom prst="rect">
+            <a:avLst/>
+          </a:prstGeom>
+          <a:solidFill>
+            <a:srgbClr val="FFFFFF"/>
+          </a:solidFill>
+          <a:ln w="6350">
+            <a:solidFill>
+              <a:srgbClr val="D9D9D9"/>
+            </a:solidFill>
+          </a:ln>
+        </p:spPr>
+        <p:txBody>
+          <a:bodyPr wrap="square" lIns="90000" tIns="40000" rIns="90000" bIns="40000" anchor="ctr"/>
+          <a:lstStyle/>
+          <a:p>
+            <a:pPr indent="0" marL="0">
+              <a:buNone/>
+            </a:pPr>
+            <a:r>
+              <a:rPr lang="en-US" sz="1050" b="1" dirty="0">
+                <a:solidFill>
+                  <a:srgbClr val="1A2233"/>
+                </a:solidFill>
+                <a:latin typeface="Calibri" pitchFamily="34" charset="0"/>
+              </a:rPr>
+              <a:t>Bank 2</a:t>
+            </a:r>
+          </a:p>
+        </p:txBody>
+      </p:sp>
+      <p:sp>
+        <p:nvSpPr>
+          <p:cNvPr id="20" name="TCell"/>
+          <p:cNvSpPr/>
+          <p:nvPr/>
+        </p:nvSpPr>
+        <p:spPr>
+          <a:xfrm>
+            <a:off x="2648640" y="2950000"/>
+            <a:ext cx="2900000" cy="700000"/>
+          </a:xfrm>
+          <a:prstGeom prst="rect">
+            <a:avLst/>
+          </a:prstGeom>
+          <a:solidFill>
+            <a:srgbClr val="FFFFFF"/>
+          </a:solidFill>
+          <a:ln w="6350">
+            <a:solidFill>
+              <a:srgbClr val="D9D9D9"/>
+            </a:solidFill>
+          </a:ln>
+        </p:spPr>
+        <p:txBody>
+          <a:bodyPr wrap="square" lIns="90000" tIns="40000" rIns="90000" bIns="40000" anchor="ctr"/>
+          <a:lstStyle/>
+          <a:p>
+            <a:pPr indent="0" marL="0">
+              <a:buNone/>
+            </a:pPr>
+            <a:r>
+              <a:rPr lang="en-US" sz="1050" dirty="0">
+                <a:solidFill>
+                  <a:srgbClr val="1A2233"/>
+                </a:solidFill>
+                <a:latin typeface="Calibri" pitchFamily="34" charset="0"/>
+              </a:rPr>
+              <a:t>Verified iOS Universal Links</a:t>
+            </a:r>
+          </a:p>
+        </p:txBody>
+      </p:sp>
+      <p:sp>
+        <p:nvSpPr>
+          <p:cNvPr id="21" name="TCell"/>
+          <p:cNvSpPr/>
+          <p:nvPr/>
+        </p:nvSpPr>
+        <p:spPr>
+          <a:xfrm>
+            <a:off x="5548640" y="2950000"/>
+            <a:ext cx="2700000" cy="700000"/>
+          </a:xfrm>
+          <a:prstGeom prst="rect">
+            <a:avLst/>
+          </a:prstGeom>
+          <a:solidFill>
+            <a:srgbClr val="FFFFFF"/>
+          </a:solidFill>
+          <a:ln w="6350">
+            <a:solidFill>
+              <a:srgbClr val="D9D9D9"/>
+            </a:solidFill>
+          </a:ln>
+        </p:spPr>
+        <p:txBody>
+          <a:bodyPr wrap="square" lIns="90000" tIns="40000" rIns="90000" bIns="40000" anchor="ctr"/>
+          <a:lstStyle/>
+          <a:p>
+            <a:pPr indent="0" marL="0">
+              <a:buNone/>
+            </a:pPr>
+            <a:r>
+              <a:rPr lang="en-US" sz="1050" dirty="0">
+                <a:solidFill>
+                  <a:srgbClr val="1A2233"/>
+                </a:solidFill>
+                <a:latin typeface="Calibri" pitchFamily="34" charset="0"/>
+              </a:rPr>
+              <a:t>Entitlement + AASA → intended silent handoff</a:t>
+            </a:r>
+          </a:p>
+        </p:txBody>
+      </p:sp>
+      <p:sp>
+        <p:nvSpPr>
+          <p:cNvPr id="22" name="TCell"/>
+          <p:cNvSpPr/>
+          <p:nvPr/>
+        </p:nvSpPr>
+        <p:spPr>
+          <a:xfrm>
+            <a:off x="8248640" y="2950000"/>
+            <a:ext cx="3400000" cy="700000"/>
+          </a:xfrm>
+          <a:prstGeom prst="rect">
+            <a:avLst/>
+          </a:prstGeom>
+          <a:solidFill>
+            <a:srgbClr val="FFE9B3"/>
+          </a:solidFill>
+          <a:ln w="6350">
+            <a:solidFill>
+              <a:srgbClr val="D9D9D9"/>
+            </a:solidFill>
+          </a:ln>
+        </p:spPr>
+        <p:txBody>
+          <a:bodyPr wrap="square" lIns="90000" tIns="40000" rIns="90000" bIns="40000" anchor="ctr"/>
+          <a:lstStyle/>
+          <a:p>
+            <a:pPr indent="0" marL="0">
+              <a:buNone/>
+            </a:pPr>
+            <a:r>
+              <a:rPr lang="en-US" sz="1050" dirty="0">
+                <a:solidFill>
+                  <a:srgbClr val="1A2233"/>
+                </a:solidFill>
+                <a:latin typeface="Calibri" pitchFamily="34" charset="0"/>
+              </a:rPr>
+              <a:t>Safari + manual banner (free-account limit)</a:t>
+            </a:r>
+          </a:p>
+        </p:txBody>
+      </p:sp>
+      <p:sp>
+        <p:nvSpPr>
+          <p:cNvPr id="23" name="TCell"/>
+          <p:cNvSpPr/>
+          <p:nvPr/>
+        </p:nvSpPr>
+        <p:spPr>
+          <a:xfrm>
+            <a:off x="548640" y="3650000"/>
+            <a:ext cx="2100000" cy="700000"/>
+          </a:xfrm>
+          <a:prstGeom prst="rect">
+            <a:avLst/>
+          </a:prstGeom>
+          <a:solidFill>
+            <a:srgbClr val="FFFFFF"/>
+          </a:solidFill>
+          <a:ln w="6350">
+            <a:solidFill>
+              <a:srgbClr val="D9D9D9"/>
+            </a:solidFill>
+          </a:ln>
+        </p:spPr>
+        <p:txBody>
+          <a:bodyPr wrap="square" lIns="90000" tIns="40000" rIns="90000" bIns="40000" anchor="ctr"/>
+          <a:lstStyle/>
+          <a:p>
+            <a:pPr indent="0" marL="0">
+              <a:buNone/>
+            </a:pPr>
+            <a:r>
+              <a:rPr lang="en-US" sz="1050" b="1" dirty="0">
+                <a:solidFill>
+                  <a:srgbClr val="1A2233"/>
+                </a:solidFill>
+                <a:latin typeface="Calibri" pitchFamily="34" charset="0"/>
+              </a:rPr>
+              <a:t>Bank 3</a:t>
+            </a:r>
+          </a:p>
+        </p:txBody>
+      </p:sp>
+      <p:sp>
+        <p:nvSpPr>
+          <p:cNvPr id="24" name="TCell"/>
+          <p:cNvSpPr/>
+          <p:nvPr/>
+        </p:nvSpPr>
+        <p:spPr>
+          <a:xfrm>
+            <a:off x="2648640" y="3650000"/>
+            <a:ext cx="2900000" cy="700000"/>
+          </a:xfrm>
+          <a:prstGeom prst="rect">
+            <a:avLst/>
+          </a:prstGeom>
+          <a:solidFill>
+            <a:srgbClr val="FFFFFF"/>
+          </a:solidFill>
+          <a:ln w="6350">
+            <a:solidFill>
+              <a:srgbClr val="D9D9D9"/>
+            </a:solidFill>
+          </a:ln>
+        </p:spPr>
+        <p:txBody>
+          <a:bodyPr wrap="square" lIns="90000" tIns="40000" rIns="90000" bIns="40000" anchor="ctr"/>
+          <a:lstStyle/>
+          <a:p>
+            <a:pPr indent="0" marL="0">
+              <a:buNone/>
+            </a:pPr>
+            <a:r>
+              <a:rPr lang="en-US" sz="1050" dirty="0">
+                <a:solidFill>
+                  <a:srgbClr val="1A2233"/>
+                </a:solidFill>
+                <a:latin typeface="Calibri" pitchFamily="34" charset="0"/>
+              </a:rPr>
+              <a:t>iOS Smart App Banner</a:t>
+            </a:r>
+          </a:p>
+        </p:txBody>
+      </p:sp>
+      <p:sp>
+        <p:nvSpPr>
+          <p:cNvPr id="25" name="TCell"/>
+          <p:cNvSpPr/>
+          <p:nvPr/>
+        </p:nvSpPr>
+        <p:spPr>
+          <a:xfrm>
+            <a:off x="5548640" y="3650000"/>
+            <a:ext cx="2700000" cy="700000"/>
+          </a:xfrm>
+          <a:prstGeom prst="rect">
+            <a:avLst/>
+          </a:prstGeom>
+          <a:solidFill>
+            <a:srgbClr val="FFFFFF"/>
+          </a:solidFill>
+          <a:ln w="6350">
+            <a:solidFill>
+              <a:srgbClr val="D9D9D9"/>
+            </a:solidFill>
+          </a:ln>
+        </p:spPr>
+        <p:txBody>
+          <a:bodyPr wrap="square" lIns="90000" tIns="40000" rIns="90000" bIns="40000" anchor="ctr"/>
+          <a:lstStyle/>
+          <a:p>
+            <a:pPr indent="0" marL="0">
+              <a:buNone/>
+            </a:pPr>
+            <a:r>
+              <a:rPr lang="en-US" sz="1050" dirty="0">
+                <a:solidFill>
+                  <a:srgbClr val="1A2233"/>
+                </a:solidFill>
+                <a:latin typeface="Calibri" pitchFamily="34" charset="0"/>
+              </a:rPr>
+              <a:t>Webpage &lt;meta&gt; tag → Safari-rendered banner</a:t>
+            </a:r>
+          </a:p>
+        </p:txBody>
+      </p:sp>
+      <p:sp>
+        <p:nvSpPr>
+          <p:cNvPr id="26" name="TCell"/>
+          <p:cNvSpPr/>
+          <p:nvPr/>
+        </p:nvSpPr>
+        <p:spPr>
+          <a:xfrm>
+            <a:off x="8248640" y="3650000"/>
+            <a:ext cx="3400000" cy="700000"/>
+          </a:xfrm>
+          <a:prstGeom prst="rect">
+            <a:avLst/>
+          </a:prstGeom>
+          <a:solidFill>
+            <a:srgbClr val="FFE9B3"/>
+          </a:solidFill>
+          <a:ln w="6350">
+            <a:solidFill>
+              <a:srgbClr val="D9D9D9"/>
+            </a:solidFill>
+          </a:ln>
+        </p:spPr>
+        <p:txBody>
+          <a:bodyPr wrap="square" lIns="90000" tIns="40000" rIns="90000" bIns="40000" anchor="ctr"/>
+          <a:lstStyle/>
+          <a:p>
+            <a:pPr indent="0" marL="0">
+              <a:buNone/>
+            </a:pPr>
+            <a:r>
+              <a:rPr lang="en-US" sz="1050" dirty="0">
+                <a:solidFill>
+                  <a:srgbClr val="1A2233"/>
+                </a:solidFill>
+                <a:latin typeface="Calibri" pitchFamily="34" charset="0"/>
+              </a:rPr>
+              <a:t>Banner can't render (needs App Store listing)</a:t>
+            </a:r>
+          </a:p>
+        </p:txBody>
+      </p:sp>
+      <p:sp>
+        <p:nvSpPr>
+          <p:cNvPr id="27" name="TCell"/>
+          <p:cNvSpPr/>
+          <p:nvPr/>
+        </p:nvSpPr>
+        <p:spPr>
+          <a:xfrm>
+            <a:off x="548640" y="4350000"/>
+            <a:ext cx="2100000" cy="700000"/>
+          </a:xfrm>
+          <a:prstGeom prst="rect">
+            <a:avLst/>
+          </a:prstGeom>
+          <a:solidFill>
+            <a:srgbClr val="FFFFFF"/>
+          </a:solidFill>
+          <a:ln w="6350">
+            <a:solidFill>
+              <a:srgbClr val="D9D9D9"/>
+            </a:solidFill>
+          </a:ln>
+        </p:spPr>
+        <p:txBody>
+          <a:bodyPr wrap="square" lIns="90000" tIns="40000" rIns="90000" bIns="40000" anchor="ctr"/>
+          <a:lstStyle/>
+          <a:p>
+            <a:pPr indent="0" marL="0">
+              <a:buNone/>
+            </a:pPr>
+            <a:r>
+              <a:rPr lang="en-US" sz="1050" b="1" dirty="0">
+                <a:solidFill>
+                  <a:srgbClr val="1A2233"/>
+                </a:solidFill>
+                <a:latin typeface="Calibri" pitchFamily="34" charset="0"/>
+              </a:rPr>
+              <a:t>Bank 4</a:t>
+            </a:r>
+          </a:p>
+        </p:txBody>
+      </p:sp>
+      <p:sp>
+        <p:nvSpPr>
+          <p:cNvPr id="28" name="TCell"/>
+          <p:cNvSpPr/>
+          <p:nvPr/>
+        </p:nvSpPr>
+        <p:spPr>
+          <a:xfrm>
+            <a:off x="2648640" y="4350000"/>
+            <a:ext cx="2900000" cy="700000"/>
+          </a:xfrm>
+          <a:prstGeom prst="rect">
+            <a:avLst/>
+          </a:prstGeom>
+          <a:solidFill>
+            <a:srgbClr val="FFFFFF"/>
+          </a:solidFill>
+          <a:ln w="6350">
+            <a:solidFill>
+              <a:srgbClr val="D9D9D9"/>
+            </a:solidFill>
+          </a:ln>
+        </p:spPr>
+        <p:txBody>
+          <a:bodyPr wrap="square" lIns="90000" tIns="40000" rIns="90000" bIns="40000" anchor="ctr"/>
+          <a:lstStyle/>
+          <a:p>
+            <a:pPr indent="0" marL="0">
+              <a:buNone/>
+            </a:pPr>
+            <a:r>
+              <a:rPr lang="en-US" sz="1050" dirty="0">
+                <a:solidFill>
+                  <a:srgbClr val="1A2233"/>
+                </a:solidFill>
+                <a:latin typeface="Calibri" pitchFamily="34" charset="0"/>
+              </a:rPr>
+              <a:t>Android Explicit-Package Intent</a:t>
+            </a:r>
+          </a:p>
+        </p:txBody>
+      </p:sp>
+      <p:sp>
+        <p:nvSpPr>
+          <p:cNvPr id="29" name="TCell"/>
+          <p:cNvSpPr/>
+          <p:nvPr/>
+        </p:nvSpPr>
+        <p:spPr>
+          <a:xfrm>
+            <a:off x="5548640" y="4350000"/>
+            <a:ext cx="2700000" cy="700000"/>
+          </a:xfrm>
+          <a:prstGeom prst="rect">
+            <a:avLst/>
+          </a:prstGeom>
+          <a:solidFill>
+            <a:srgbClr val="FFFFFF"/>
+          </a:solidFill>
+          <a:ln w="6350">
+            <a:solidFill>
+              <a:srgbClr val="D9D9D9"/>
+            </a:solidFill>
+          </a:ln>
+        </p:spPr>
+        <p:txBody>
+          <a:bodyPr wrap="square" lIns="90000" tIns="40000" rIns="90000" bIns="40000" anchor="ctr"/>
+          <a:lstStyle/>
+          <a:p>
+            <a:pPr indent="0" marL="0">
+              <a:buNone/>
+            </a:pPr>
+            <a:r>
+              <a:rPr lang="en-US" sz="1050" dirty="0">
+                <a:solidFill>
+                  <a:srgbClr val="1A2233"/>
+                </a:solidFill>
+                <a:latin typeface="Calibri" pitchFamily="34" charset="0"/>
+              </a:rPr>
+              <a:t>Sender names the exact package → direct launch</a:t>
+            </a:r>
+          </a:p>
+        </p:txBody>
+      </p:sp>
+      <p:sp>
+        <p:nvSpPr>
+          <p:cNvPr id="30" name="TCell"/>
+          <p:cNvSpPr/>
+          <p:nvPr/>
+        </p:nvSpPr>
+        <p:spPr>
+          <a:xfrm>
+            <a:off x="8248640" y="4350000"/>
+            <a:ext cx="3400000" cy="700000"/>
+          </a:xfrm>
+          <a:prstGeom prst="rect">
+            <a:avLst/>
+          </a:prstGeom>
+          <a:solidFill>
+            <a:srgbClr val="E8F5F0"/>
+          </a:solidFill>
+          <a:ln w="6350">
+            <a:solidFill>
+              <a:srgbClr val="D9D9D9"/>
+            </a:solidFill>
+          </a:ln>
+        </p:spPr>
+        <p:txBody>
+          <a:bodyPr wrap="square" lIns="90000" tIns="40000" rIns="90000" bIns="40000" anchor="ctr"/>
+          <a:lstStyle/>
+          <a:p>
+            <a:pPr indent="0" marL="0">
+              <a:buNone/>
+            </a:pPr>
+            <a:r>
+              <a:rPr lang="en-US" sz="1050" dirty="0">
+                <a:solidFill>
+                  <a:srgbClr val="1A2233"/>
+                </a:solidFill>
+                <a:latin typeface="Calibri" pitchFamily="34" charset="0"/>
+              </a:rPr>
+              <a:t>Opens directly, zero prompt</a:t>
+            </a:r>
+          </a:p>
+        </p:txBody>
+      </p:sp>
+      <p:sp>
+        <p:nvSpPr>
+          <p:cNvPr id="31" name="TCell"/>
+          <p:cNvSpPr/>
+          <p:nvPr/>
+        </p:nvSpPr>
+        <p:spPr>
+          <a:xfrm>
+            <a:off x="548640" y="5050000"/>
+            <a:ext cx="2100000" cy="700000"/>
+          </a:xfrm>
+          <a:prstGeom prst="rect">
+            <a:avLst/>
+          </a:prstGeom>
+          <a:solidFill>
+            <a:srgbClr val="FFFFFF"/>
+          </a:solidFill>
+          <a:ln w="6350">
+            <a:solidFill>
+              <a:srgbClr val="D9D9D9"/>
+            </a:solidFill>
+          </a:ln>
+        </p:spPr>
+        <p:txBody>
+          <a:bodyPr wrap="square" lIns="90000" tIns="40000" rIns="90000" bIns="40000" anchor="ctr"/>
+          <a:lstStyle/>
+          <a:p>
+            <a:pPr indent="0" marL="0">
+              <a:buNone/>
+            </a:pPr>
+            <a:r>
+              <a:rPr lang="en-US" sz="1050" b="1" dirty="0">
+                <a:solidFill>
+                  <a:srgbClr val="1A2233"/>
+                </a:solidFill>
+                <a:latin typeface="Calibri" pitchFamily="34" charset="0"/>
+              </a:rPr>
+              <a:t>Bank 5</a:t>
+            </a:r>
+          </a:p>
+        </p:txBody>
+      </p:sp>
+      <p:sp>
+        <p:nvSpPr>
+          <p:cNvPr id="32" name="TCell"/>
+          <p:cNvSpPr/>
+          <p:nvPr/>
+        </p:nvSpPr>
+        <p:spPr>
+          <a:xfrm>
+            <a:off x="2648640" y="5050000"/>
+            <a:ext cx="2900000" cy="700000"/>
+          </a:xfrm>
+          <a:prstGeom prst="rect">
+            <a:avLst/>
+          </a:prstGeom>
+          <a:solidFill>
+            <a:srgbClr val="FFFFFF"/>
+          </a:solidFill>
+          <a:ln w="6350">
+            <a:solidFill>
+              <a:srgbClr val="D9D9D9"/>
+            </a:solidFill>
+          </a:ln>
+        </p:spPr>
+        <p:txBody>
+          <a:bodyPr wrap="square" lIns="90000" tIns="40000" rIns="90000" bIns="40000" anchor="ctr"/>
+          <a:lstStyle/>
+          <a:p>
+            <a:pPr indent="0" marL="0">
+              <a:buNone/>
+            </a:pPr>
+            <a:r>
+              <a:rPr lang="en-US" sz="1050" dirty="0">
+                <a:solidFill>
+                  <a:srgbClr val="1A2233"/>
+                </a:solidFill>
+                <a:latin typeface="Calibri" pitchFamily="34" charset="0"/>
+              </a:rPr>
+              <a:t>Deferred Deep Linking</a:t>
+            </a:r>
+          </a:p>
+        </p:txBody>
+      </p:sp>
+      <p:sp>
+        <p:nvSpPr>
+          <p:cNvPr id="33" name="TCell"/>
+          <p:cNvSpPr/>
+          <p:nvPr/>
+        </p:nvSpPr>
+        <p:spPr>
+          <a:xfrm>
+            <a:off x="5548640" y="5050000"/>
+            <a:ext cx="2700000" cy="700000"/>
+          </a:xfrm>
+          <a:prstGeom prst="rect">
+            <a:avLst/>
+          </a:prstGeom>
+          <a:solidFill>
+            <a:srgbClr val="FFFFFF"/>
+          </a:solidFill>
+          <a:ln w="6350">
+            <a:solidFill>
+              <a:srgbClr val="D9D9D9"/>
+            </a:solidFill>
+          </a:ln>
+        </p:spPr>
+        <p:txBody>
+          <a:bodyPr wrap="square" lIns="90000" tIns="40000" rIns="90000" bIns="40000" anchor="ctr"/>
+          <a:lstStyle/>
+          <a:p>
+            <a:pPr indent="0" marL="0">
+              <a:buNone/>
+            </a:pPr>
+            <a:r>
+              <a:rPr lang="en-US" sz="1050" dirty="0">
+                <a:solidFill>
+                  <a:srgbClr val="1A2233"/>
+                </a:solidFill>
+                <a:latin typeface="Calibri" pitchFamily="34" charset="0"/>
+              </a:rPr>
+              <a:t>Clipboard carries the token across install</a:t>
+            </a:r>
+          </a:p>
+        </p:txBody>
+      </p:sp>
+      <p:sp>
+        <p:nvSpPr>
+          <p:cNvPr id="34" name="TCell"/>
+          <p:cNvSpPr/>
+          <p:nvPr/>
+        </p:nvSpPr>
+        <p:spPr>
+          <a:xfrm>
+            <a:off x="8248640" y="5050000"/>
+            <a:ext cx="3400000" cy="700000"/>
+          </a:xfrm>
+          <a:prstGeom prst="rect">
+            <a:avLst/>
+          </a:prstGeom>
+          <a:solidFill>
+            <a:srgbClr val="E8F5F0"/>
+          </a:solidFill>
+          <a:ln w="6350">
+            <a:solidFill>
+              <a:srgbClr val="D9D9D9"/>
+            </a:solidFill>
+          </a:ln>
+        </p:spPr>
+        <p:txBody>
+          <a:bodyPr wrap="square" lIns="90000" tIns="40000" rIns="90000" bIns="40000" anchor="ctr"/>
+          <a:lstStyle/>
+          <a:p>
+            <a:pPr indent="0" marL="0">
+              <a:buNone/>
+            </a:pPr>
+            <a:r>
+              <a:rPr lang="en-US" sz="1050" dirty="0">
+                <a:solidFill>
+                  <a:srgbClr val="1A2233"/>
+                </a:solidFill>
+                <a:latin typeface="Calibri" pitchFamily="34" charset="0"/>
+              </a:rPr>
+              <a:t>Correct token recovered, both platforms</a:t>
+            </a:r>
+          </a:p>
+        </p:txBody>
+      </p:sp>
+      <p:sp>
+        <p:nvSpPr>
+          <p:cNvPr id="900" name="Footer"/>
+          <p:cNvSpPr/>
+          <p:nvPr/>
+        </p:nvSpPr>
+        <p:spPr>
+          <a:xfrm>
+            <a:off x="548640" y="5900000"/>
+            <a:ext cx="11094720" cy="500000"/>
+          </a:xfrm>
+          <a:prstGeom prst="rect">
+            <a:avLst/>
+          </a:prstGeom>
+          <a:noFill/>
+          <a:ln/>
+        </p:spPr>
+        <p:txBody>
+          <a:bodyPr wrap="square" lIns="0" tIns="0" rIns="0" bIns="0" anchor="t"/>
+          <a:lstStyle/>
+          <a:p>
+            <a:pPr indent="0" marL="0">
+              <a:buNone/>
+            </a:pPr>
+            <a:r>
+              <a:rPr lang="en-US" sz="1200" i="1" dirty="0">
+                <a:solidFill>
+                  <a:srgbClr val="5B6B79"/>
+                </a:solidFill>
+                <a:latin typeface="Calibri" pitchFamily="34" charset="0"/>
+              </a:rPr>
+              <a:t>See the preceding two slides for the full step-by-step sequence behind Bank 1's direct launch and the Bank 2 cross-platform negative case.</a:t>
+            </a:r>
+          </a:p>
+        </p:txBody>
+      </p:sp>
     </p:spTree>
   </p:cSld>
   <p:clrMapOvr>

</xml_diff>

<commit_message>
Include unregistered link in sequence deck's all-methods summary
The "All 5 Methods" summary table only listed Bank 1-5, omitting the
core unregistered-link approach (Bank A/B/C). Retitled to "All 6
Methods" and added it as the first row for consistency with the main
deck and Word doc, which already include it in their comparisons.

Co-Authored-By: Claude Sonnet 5 <noreply@anthropic.com>
</commit_message>
<xml_diff>
--- a/SGQR_Sequence_Diagrams.pptx
+++ b/SGQR_Sequence_Diagrams.pptx
@@ -7022,7 +7022,7 @@
                 <a:ea typeface="Cambria" pitchFamily="34" charset="-122"/>
                 <a:cs typeface="Cambria" pitchFamily="34" charset="-120"/>
               </a:rPr>
-              <a:t>All 5 Methods, Sequence by Sequence</a:t>
+              <a:t>All 6 Methods, Sequence by Sequence</a:t>
             </a:r>
           </a:p>
         </p:txBody>
@@ -7060,7 +7060,7 @@
                 <a:ea typeface="Calibri" pitchFamily="34" charset="-122"/>
                 <a:cs typeface="Calibri" pitchFamily="34" charset="-120"/>
               </a:rPr>
-              <a:t>Bank 1 through Bank 5 — how each one actually resolves, confirmed live on real devices</a:t>
+              <a:t>The core approach plus all 5 alternative methods — how each one actually resolves, confirmed live on real devices</a:t>
             </a:r>
           </a:p>
         </p:txBody>
@@ -7234,7 +7234,7 @@
         <p:spPr>
           <a:xfrm>
             <a:off x="548640" y="2250000"/>
-            <a:ext cx="2100000" cy="700000"/>
+            <a:ext cx="2100000" cy="620000"/>
           </a:xfrm>
           <a:prstGeom prst="rect">
             <a:avLst/>
@@ -7262,6 +7262,174 @@
                 </a:solidFill>
                 <a:latin typeface="Calibri" pitchFamily="34" charset="0"/>
               </a:rPr>
+              <a:t>Unregistered link</a:t>
+            </a:r>
+          </a:p>
+        </p:txBody>
+      </p:sp>
+      <p:sp>
+        <p:nvSpPr>
+          <p:cNvPr id="16" name="TCell"/>
+          <p:cNvSpPr/>
+          <p:nvPr/>
+        </p:nvSpPr>
+        <p:spPr>
+          <a:xfrm>
+            <a:off x="2648640" y="2250000"/>
+            <a:ext cx="2900000" cy="620000"/>
+          </a:xfrm>
+          <a:prstGeom prst="rect">
+            <a:avLst/>
+          </a:prstGeom>
+          <a:solidFill>
+            <a:srgbClr val="FFFFFF"/>
+          </a:solidFill>
+          <a:ln w="6350">
+            <a:solidFill>
+              <a:srgbClr val="D9D9D9"/>
+            </a:solidFill>
+          </a:ln>
+        </p:spPr>
+        <p:txBody>
+          <a:bodyPr wrap="square" lIns="90000" tIns="40000" rIns="90000" bIns="40000" anchor="ctr"/>
+          <a:lstStyle/>
+          <a:p>
+            <a:pPr indent="0" marL="0">
+              <a:buNone/>
+            </a:pPr>
+            <a:r>
+              <a:rPr lang="en-US" sz="1050" dirty="0">
+                <a:solidFill>
+                  <a:srgbClr val="1A2233"/>
+                </a:solidFill>
+                <a:latin typeface="Calibri" pitchFamily="34" charset="0"/>
+              </a:rPr>
+              <a:t>Core approach (Bank A/B/C)</a:t>
+            </a:r>
+          </a:p>
+        </p:txBody>
+      </p:sp>
+      <p:sp>
+        <p:nvSpPr>
+          <p:cNvPr id="17" name="TCell"/>
+          <p:cNvSpPr/>
+          <p:nvPr/>
+        </p:nvSpPr>
+        <p:spPr>
+          <a:xfrm>
+            <a:off x="5548640" y="2250000"/>
+            <a:ext cx="2700000" cy="620000"/>
+          </a:xfrm>
+          <a:prstGeom prst="rect">
+            <a:avLst/>
+          </a:prstGeom>
+          <a:solidFill>
+            <a:srgbClr val="FFFFFF"/>
+          </a:solidFill>
+          <a:ln w="6350">
+            <a:solidFill>
+              <a:srgbClr val="D9D9D9"/>
+            </a:solidFill>
+          </a:ln>
+        </p:spPr>
+        <p:txBody>
+          <a:bodyPr wrap="square" lIns="90000" tIns="40000" rIns="90000" bIns="40000" anchor="ctr"/>
+          <a:lstStyle/>
+          <a:p>
+            <a:pPr indent="0" marL="0">
+              <a:buNone/>
+            </a:pPr>
+            <a:r>
+              <a:rPr lang="en-US" sz="1050" dirty="0">
+                <a:solidFill>
+                  <a:srgbClr val="1A2233"/>
+                </a:solidFill>
+                <a:latin typeface="Calibri" pitchFamily="34" charset="0"/>
+              </a:rPr>
+              <a:t>No verification → chooser/picker is the point</a:t>
+            </a:r>
+          </a:p>
+        </p:txBody>
+      </p:sp>
+      <p:sp>
+        <p:nvSpPr>
+          <p:cNvPr id="18" name="TCell"/>
+          <p:cNvSpPr/>
+          <p:nvPr/>
+        </p:nvSpPr>
+        <p:spPr>
+          <a:xfrm>
+            <a:off x="8248640" y="2250000"/>
+            <a:ext cx="3400000" cy="620000"/>
+          </a:xfrm>
+          <a:prstGeom prst="rect">
+            <a:avLst/>
+          </a:prstGeom>
+          <a:solidFill>
+            <a:srgbClr val="E8F5F0"/>
+          </a:solidFill>
+          <a:ln w="6350">
+            <a:solidFill>
+              <a:srgbClr val="D9D9D9"/>
+            </a:solidFill>
+          </a:ln>
+        </p:spPr>
+        <p:txBody>
+          <a:bodyPr wrap="square" lIns="90000" tIns="40000" rIns="90000" bIns="40000" anchor="ctr"/>
+          <a:lstStyle/>
+          <a:p>
+            <a:pPr indent="0" marL="0">
+              <a:buNone/>
+            </a:pPr>
+            <a:r>
+              <a:rPr lang="en-US" sz="1050" dirty="0">
+                <a:solidFill>
+                  <a:srgbClr val="1A2233"/>
+                </a:solidFill>
+                <a:latin typeface="Calibri" pitchFamily="34" charset="0"/>
+              </a:rPr>
+              <a:t>Working end to end, both platforms</a:t>
+            </a:r>
+          </a:p>
+        </p:txBody>
+      </p:sp>
+      <p:sp>
+        <p:nvSpPr>
+          <p:cNvPr id="19" name="TCell"/>
+          <p:cNvSpPr/>
+          <p:nvPr/>
+        </p:nvSpPr>
+        <p:spPr>
+          <a:xfrm>
+            <a:off x="548640" y="2870000"/>
+            <a:ext cx="2100000" cy="620000"/>
+          </a:xfrm>
+          <a:prstGeom prst="rect">
+            <a:avLst/>
+          </a:prstGeom>
+          <a:solidFill>
+            <a:srgbClr val="FFFFFF"/>
+          </a:solidFill>
+          <a:ln w="6350">
+            <a:solidFill>
+              <a:srgbClr val="D9D9D9"/>
+            </a:solidFill>
+          </a:ln>
+        </p:spPr>
+        <p:txBody>
+          <a:bodyPr wrap="square" lIns="90000" tIns="40000" rIns="90000" bIns="40000" anchor="ctr"/>
+          <a:lstStyle/>
+          <a:p>
+            <a:pPr indent="0" marL="0">
+              <a:buNone/>
+            </a:pPr>
+            <a:r>
+              <a:rPr lang="en-US" sz="1050" b="1" dirty="0">
+                <a:solidFill>
+                  <a:srgbClr val="1A2233"/>
+                </a:solidFill>
+                <a:latin typeface="Calibri" pitchFamily="34" charset="0"/>
+              </a:rPr>
               <a:t>Bank 1</a:t>
             </a:r>
           </a:p>
@@ -7269,14 +7437,14 @@
       </p:sp>
       <p:sp>
         <p:nvSpPr>
-          <p:cNvPr id="16" name="TCell"/>
-          <p:cNvSpPr/>
-          <p:nvPr/>
-        </p:nvSpPr>
-        <p:spPr>
-          <a:xfrm>
-            <a:off x="2648640" y="2250000"/>
-            <a:ext cx="2900000" cy="700000"/>
+          <p:cNvPr id="20" name="TCell"/>
+          <p:cNvSpPr/>
+          <p:nvPr/>
+        </p:nvSpPr>
+        <p:spPr>
+          <a:xfrm>
+            <a:off x="2648640" y="2870000"/>
+            <a:ext cx="2900000" cy="620000"/>
           </a:xfrm>
           <a:prstGeom prst="rect">
             <a:avLst/>
@@ -7311,14 +7479,14 @@
       </p:sp>
       <p:sp>
         <p:nvSpPr>
-          <p:cNvPr id="17" name="TCell"/>
-          <p:cNvSpPr/>
-          <p:nvPr/>
-        </p:nvSpPr>
-        <p:spPr>
-          <a:xfrm>
-            <a:off x="5548640" y="2250000"/>
-            <a:ext cx="2700000" cy="700000"/>
+          <p:cNvPr id="21" name="TCell"/>
+          <p:cNvSpPr/>
+          <p:nvPr/>
+        </p:nvSpPr>
+        <p:spPr>
+          <a:xfrm>
+            <a:off x="5548640" y="2870000"/>
+            <a:ext cx="2700000" cy="620000"/>
           </a:xfrm>
           <a:prstGeom prst="rect">
             <a:avLst/>
@@ -7353,14 +7521,14 @@
       </p:sp>
       <p:sp>
         <p:nvSpPr>
-          <p:cNvPr id="18" name="TCell"/>
-          <p:cNvSpPr/>
-          <p:nvPr/>
-        </p:nvSpPr>
-        <p:spPr>
-          <a:xfrm>
-            <a:off x="8248640" y="2250000"/>
-            <a:ext cx="3400000" cy="700000"/>
+          <p:cNvPr id="22" name="TCell"/>
+          <p:cNvSpPr/>
+          <p:nvPr/>
+        </p:nvSpPr>
+        <p:spPr>
+          <a:xfrm>
+            <a:off x="8248640" y="2870000"/>
+            <a:ext cx="3400000" cy="620000"/>
           </a:xfrm>
           <a:prstGeom prst="rect">
             <a:avLst/>
@@ -7395,14 +7563,14 @@
       </p:sp>
       <p:sp>
         <p:nvSpPr>
-          <p:cNvPr id="19" name="TCell"/>
-          <p:cNvSpPr/>
-          <p:nvPr/>
-        </p:nvSpPr>
-        <p:spPr>
-          <a:xfrm>
-            <a:off x="548640" y="2950000"/>
-            <a:ext cx="2100000" cy="700000"/>
+          <p:cNvPr id="23" name="TCell"/>
+          <p:cNvSpPr/>
+          <p:nvPr/>
+        </p:nvSpPr>
+        <p:spPr>
+          <a:xfrm>
+            <a:off x="548640" y="3490000"/>
+            <a:ext cx="2100000" cy="620000"/>
           </a:xfrm>
           <a:prstGeom prst="rect">
             <a:avLst/>
@@ -7437,14 +7605,14 @@
       </p:sp>
       <p:sp>
         <p:nvSpPr>
-          <p:cNvPr id="20" name="TCell"/>
-          <p:cNvSpPr/>
-          <p:nvPr/>
-        </p:nvSpPr>
-        <p:spPr>
-          <a:xfrm>
-            <a:off x="2648640" y="2950000"/>
-            <a:ext cx="2900000" cy="700000"/>
+          <p:cNvPr id="24" name="TCell"/>
+          <p:cNvSpPr/>
+          <p:nvPr/>
+        </p:nvSpPr>
+        <p:spPr>
+          <a:xfrm>
+            <a:off x="2648640" y="3490000"/>
+            <a:ext cx="2900000" cy="620000"/>
           </a:xfrm>
           <a:prstGeom prst="rect">
             <a:avLst/>
@@ -7479,14 +7647,14 @@
       </p:sp>
       <p:sp>
         <p:nvSpPr>
-          <p:cNvPr id="21" name="TCell"/>
-          <p:cNvSpPr/>
-          <p:nvPr/>
-        </p:nvSpPr>
-        <p:spPr>
-          <a:xfrm>
-            <a:off x="5548640" y="2950000"/>
-            <a:ext cx="2700000" cy="700000"/>
+          <p:cNvPr id="25" name="TCell"/>
+          <p:cNvSpPr/>
+          <p:nvPr/>
+        </p:nvSpPr>
+        <p:spPr>
+          <a:xfrm>
+            <a:off x="5548640" y="3490000"/>
+            <a:ext cx="2700000" cy="620000"/>
           </a:xfrm>
           <a:prstGeom prst="rect">
             <a:avLst/>
@@ -7521,14 +7689,14 @@
       </p:sp>
       <p:sp>
         <p:nvSpPr>
-          <p:cNvPr id="22" name="TCell"/>
-          <p:cNvSpPr/>
-          <p:nvPr/>
-        </p:nvSpPr>
-        <p:spPr>
-          <a:xfrm>
-            <a:off x="8248640" y="2950000"/>
-            <a:ext cx="3400000" cy="700000"/>
+          <p:cNvPr id="26" name="TCell"/>
+          <p:cNvSpPr/>
+          <p:nvPr/>
+        </p:nvSpPr>
+        <p:spPr>
+          <a:xfrm>
+            <a:off x="8248640" y="3490000"/>
+            <a:ext cx="3400000" cy="620000"/>
           </a:xfrm>
           <a:prstGeom prst="rect">
             <a:avLst/>
@@ -7563,14 +7731,14 @@
       </p:sp>
       <p:sp>
         <p:nvSpPr>
-          <p:cNvPr id="23" name="TCell"/>
-          <p:cNvSpPr/>
-          <p:nvPr/>
-        </p:nvSpPr>
-        <p:spPr>
-          <a:xfrm>
-            <a:off x="548640" y="3650000"/>
-            <a:ext cx="2100000" cy="700000"/>
+          <p:cNvPr id="27" name="TCell"/>
+          <p:cNvSpPr/>
+          <p:nvPr/>
+        </p:nvSpPr>
+        <p:spPr>
+          <a:xfrm>
+            <a:off x="548640" y="4110000"/>
+            <a:ext cx="2100000" cy="620000"/>
           </a:xfrm>
           <a:prstGeom prst="rect">
             <a:avLst/>
@@ -7605,14 +7773,14 @@
       </p:sp>
       <p:sp>
         <p:nvSpPr>
-          <p:cNvPr id="24" name="TCell"/>
-          <p:cNvSpPr/>
-          <p:nvPr/>
-        </p:nvSpPr>
-        <p:spPr>
-          <a:xfrm>
-            <a:off x="2648640" y="3650000"/>
-            <a:ext cx="2900000" cy="700000"/>
+          <p:cNvPr id="28" name="TCell"/>
+          <p:cNvSpPr/>
+          <p:nvPr/>
+        </p:nvSpPr>
+        <p:spPr>
+          <a:xfrm>
+            <a:off x="2648640" y="4110000"/>
+            <a:ext cx="2900000" cy="620000"/>
           </a:xfrm>
           <a:prstGeom prst="rect">
             <a:avLst/>
@@ -7647,14 +7815,14 @@
       </p:sp>
       <p:sp>
         <p:nvSpPr>
-          <p:cNvPr id="25" name="TCell"/>
-          <p:cNvSpPr/>
-          <p:nvPr/>
-        </p:nvSpPr>
-        <p:spPr>
-          <a:xfrm>
-            <a:off x="5548640" y="3650000"/>
-            <a:ext cx="2700000" cy="700000"/>
+          <p:cNvPr id="29" name="TCell"/>
+          <p:cNvSpPr/>
+          <p:nvPr/>
+        </p:nvSpPr>
+        <p:spPr>
+          <a:xfrm>
+            <a:off x="5548640" y="4110000"/>
+            <a:ext cx="2700000" cy="620000"/>
           </a:xfrm>
           <a:prstGeom prst="rect">
             <a:avLst/>
@@ -7689,14 +7857,14 @@
       </p:sp>
       <p:sp>
         <p:nvSpPr>
-          <p:cNvPr id="26" name="TCell"/>
-          <p:cNvSpPr/>
-          <p:nvPr/>
-        </p:nvSpPr>
-        <p:spPr>
-          <a:xfrm>
-            <a:off x="8248640" y="3650000"/>
-            <a:ext cx="3400000" cy="700000"/>
+          <p:cNvPr id="30" name="TCell"/>
+          <p:cNvSpPr/>
+          <p:nvPr/>
+        </p:nvSpPr>
+        <p:spPr>
+          <a:xfrm>
+            <a:off x="8248640" y="4110000"/>
+            <a:ext cx="3400000" cy="620000"/>
           </a:xfrm>
           <a:prstGeom prst="rect">
             <a:avLst/>
@@ -7731,14 +7899,14 @@
       </p:sp>
       <p:sp>
         <p:nvSpPr>
-          <p:cNvPr id="27" name="TCell"/>
-          <p:cNvSpPr/>
-          <p:nvPr/>
-        </p:nvSpPr>
-        <p:spPr>
-          <a:xfrm>
-            <a:off x="548640" y="4350000"/>
-            <a:ext cx="2100000" cy="700000"/>
+          <p:cNvPr id="31" name="TCell"/>
+          <p:cNvSpPr/>
+          <p:nvPr/>
+        </p:nvSpPr>
+        <p:spPr>
+          <a:xfrm>
+            <a:off x="548640" y="4730000"/>
+            <a:ext cx="2100000" cy="620000"/>
           </a:xfrm>
           <a:prstGeom prst="rect">
             <a:avLst/>
@@ -7773,14 +7941,14 @@
       </p:sp>
       <p:sp>
         <p:nvSpPr>
-          <p:cNvPr id="28" name="TCell"/>
-          <p:cNvSpPr/>
-          <p:nvPr/>
-        </p:nvSpPr>
-        <p:spPr>
-          <a:xfrm>
-            <a:off x="2648640" y="4350000"/>
-            <a:ext cx="2900000" cy="700000"/>
+          <p:cNvPr id="32" name="TCell"/>
+          <p:cNvSpPr/>
+          <p:nvPr/>
+        </p:nvSpPr>
+        <p:spPr>
+          <a:xfrm>
+            <a:off x="2648640" y="4730000"/>
+            <a:ext cx="2900000" cy="620000"/>
           </a:xfrm>
           <a:prstGeom prst="rect">
             <a:avLst/>
@@ -7815,14 +7983,14 @@
       </p:sp>
       <p:sp>
         <p:nvSpPr>
-          <p:cNvPr id="29" name="TCell"/>
-          <p:cNvSpPr/>
-          <p:nvPr/>
-        </p:nvSpPr>
-        <p:spPr>
-          <a:xfrm>
-            <a:off x="5548640" y="4350000"/>
-            <a:ext cx="2700000" cy="700000"/>
+          <p:cNvPr id="33" name="TCell"/>
+          <p:cNvSpPr/>
+          <p:nvPr/>
+        </p:nvSpPr>
+        <p:spPr>
+          <a:xfrm>
+            <a:off x="5548640" y="4730000"/>
+            <a:ext cx="2700000" cy="620000"/>
           </a:xfrm>
           <a:prstGeom prst="rect">
             <a:avLst/>
@@ -7857,14 +8025,14 @@
       </p:sp>
       <p:sp>
         <p:nvSpPr>
-          <p:cNvPr id="30" name="TCell"/>
-          <p:cNvSpPr/>
-          <p:nvPr/>
-        </p:nvSpPr>
-        <p:spPr>
-          <a:xfrm>
-            <a:off x="8248640" y="4350000"/>
-            <a:ext cx="3400000" cy="700000"/>
+          <p:cNvPr id="34" name="TCell"/>
+          <p:cNvSpPr/>
+          <p:nvPr/>
+        </p:nvSpPr>
+        <p:spPr>
+          <a:xfrm>
+            <a:off x="8248640" y="4730000"/>
+            <a:ext cx="3400000" cy="620000"/>
           </a:xfrm>
           <a:prstGeom prst="rect">
             <a:avLst/>
@@ -7899,14 +8067,14 @@
       </p:sp>
       <p:sp>
         <p:nvSpPr>
-          <p:cNvPr id="31" name="TCell"/>
-          <p:cNvSpPr/>
-          <p:nvPr/>
-        </p:nvSpPr>
-        <p:spPr>
-          <a:xfrm>
-            <a:off x="548640" y="5050000"/>
-            <a:ext cx="2100000" cy="700000"/>
+          <p:cNvPr id="35" name="TCell"/>
+          <p:cNvSpPr/>
+          <p:nvPr/>
+        </p:nvSpPr>
+        <p:spPr>
+          <a:xfrm>
+            <a:off x="548640" y="5350000"/>
+            <a:ext cx="2100000" cy="620000"/>
           </a:xfrm>
           <a:prstGeom prst="rect">
             <a:avLst/>
@@ -7941,14 +8109,14 @@
       </p:sp>
       <p:sp>
         <p:nvSpPr>
-          <p:cNvPr id="32" name="TCell"/>
-          <p:cNvSpPr/>
-          <p:nvPr/>
-        </p:nvSpPr>
-        <p:spPr>
-          <a:xfrm>
-            <a:off x="2648640" y="5050000"/>
-            <a:ext cx="2900000" cy="700000"/>
+          <p:cNvPr id="36" name="TCell"/>
+          <p:cNvSpPr/>
+          <p:nvPr/>
+        </p:nvSpPr>
+        <p:spPr>
+          <a:xfrm>
+            <a:off x="2648640" y="5350000"/>
+            <a:ext cx="2900000" cy="620000"/>
           </a:xfrm>
           <a:prstGeom prst="rect">
             <a:avLst/>
@@ -7983,14 +8151,14 @@
       </p:sp>
       <p:sp>
         <p:nvSpPr>
-          <p:cNvPr id="33" name="TCell"/>
-          <p:cNvSpPr/>
-          <p:nvPr/>
-        </p:nvSpPr>
-        <p:spPr>
-          <a:xfrm>
-            <a:off x="5548640" y="5050000"/>
-            <a:ext cx="2700000" cy="700000"/>
+          <p:cNvPr id="37" name="TCell"/>
+          <p:cNvSpPr/>
+          <p:nvPr/>
+        </p:nvSpPr>
+        <p:spPr>
+          <a:xfrm>
+            <a:off x="5548640" y="5350000"/>
+            <a:ext cx="2700000" cy="620000"/>
           </a:xfrm>
           <a:prstGeom prst="rect">
             <a:avLst/>
@@ -8025,14 +8193,14 @@
       </p:sp>
       <p:sp>
         <p:nvSpPr>
-          <p:cNvPr id="34" name="TCell"/>
-          <p:cNvSpPr/>
-          <p:nvPr/>
-        </p:nvSpPr>
-        <p:spPr>
-          <a:xfrm>
-            <a:off x="8248640" y="5050000"/>
-            <a:ext cx="3400000" cy="700000"/>
+          <p:cNvPr id="38" name="TCell"/>
+          <p:cNvSpPr/>
+          <p:nvPr/>
+        </p:nvSpPr>
+        <p:spPr>
+          <a:xfrm>
+            <a:off x="8248640" y="5350000"/>
+            <a:ext cx="3400000" cy="620000"/>
           </a:xfrm>
           <a:prstGeom prst="rect">
             <a:avLst/>
@@ -8073,7 +8241,7 @@
         </p:nvSpPr>
         <p:spPr>
           <a:xfrm>
-            <a:off x="548640" y="5900000"/>
+            <a:off x="548640" y="6120000"/>
             <a:ext cx="11094720" cy="500000"/>
           </a:xfrm>
           <a:prstGeom prst="rect">

</xml_diff>